<commit_message>
assets: update default template images and source pptx
</commit_message>
<xml_diff>
--- a/ym4cut_template.pptx
+++ b/ym4cut_template.pptx
@@ -2,13 +2,18 @@
 <file path=ppt/presentation.xml><?xml version="1.0" encoding="utf-8"?>
 <p:presentation xmlns:a="http://schemas.openxmlformats.org/drawingml/2006/main" xmlns:r="http://schemas.openxmlformats.org/officeDocument/2006/relationships" xmlns:p="http://schemas.openxmlformats.org/presentationml/2006/main" saveSubsetFonts="1">
   <p:sldMasterIdLst>
-    <p:sldMasterId id="2147483660" r:id="rId1"/>
+    <p:sldMasterId id="2147483672" r:id="rId1"/>
   </p:sldMasterIdLst>
+  <p:notesMasterIdLst>
+    <p:notesMasterId r:id="rId6"/>
+  </p:notesMasterIdLst>
   <p:sldIdLst>
     <p:sldId id="259" r:id="rId2"/>
     <p:sldId id="260" r:id="rId3"/>
+    <p:sldId id="263" r:id="rId4"/>
+    <p:sldId id="264" r:id="rId5"/>
   </p:sldIdLst>
-  <p:sldSz cx="6858000" cy="12192000"/>
+  <p:sldSz cx="3600450" cy="10655300"/>
   <p:notesSz cx="6858000" cy="9144000"/>
   <p:defaultTextStyle>
     <a:defPPr>
@@ -108,12 +113,12 @@
   <p:extLst>
     <p:ext uri="{EFAFB233-063F-42B5-8137-9DF3F51BA10A}">
       <p15:sldGuideLst xmlns:p15="http://schemas.microsoft.com/office/powerpoint/2012/main">
-        <p15:guide id="1" orient="horz" pos="3840" userDrawn="1">
+        <p15:guide id="1" orient="horz" pos="3356" userDrawn="1">
           <p15:clr>
             <a:srgbClr val="A4A3A4"/>
           </p15:clr>
         </p15:guide>
-        <p15:guide id="2" pos="2160" userDrawn="1">
+        <p15:guide id="2" pos="1134" userDrawn="1">
           <p15:clr>
             <a:srgbClr val="A4A3A4"/>
           </p15:clr>
@@ -122,6 +127,614 @@
     </p:ext>
   </p:extLst>
 </p:presentation>
+</file>
+
+<file path=ppt/notesMasters/notesMaster1.xml><?xml version="1.0" encoding="utf-8"?>
+<p:notesMaster xmlns:a="http://schemas.openxmlformats.org/drawingml/2006/main" xmlns:r="http://schemas.openxmlformats.org/officeDocument/2006/relationships" xmlns:p="http://schemas.openxmlformats.org/presentationml/2006/main">
+  <p:cSld>
+    <p:bg>
+      <p:bgRef idx="1001">
+        <a:schemeClr val="bg1"/>
+      </p:bgRef>
+    </p:bg>
+    <p:spTree>
+      <p:nvGrpSpPr>
+        <p:cNvPr id="1" name=""/>
+        <p:cNvGrpSpPr/>
+        <p:nvPr/>
+      </p:nvGrpSpPr>
+      <p:grpSpPr>
+        <a:xfrm>
+          <a:off x="0" y="0"/>
+          <a:ext cx="0" cy="0"/>
+          <a:chOff x="0" y="0"/>
+          <a:chExt cx="0" cy="0"/>
+        </a:xfrm>
+      </p:grpSpPr>
+      <p:sp>
+        <p:nvSpPr>
+          <p:cNvPr id="2" name="머리글 개체 틀 1"/>
+          <p:cNvSpPr>
+            <a:spLocks noGrp="1"/>
+          </p:cNvSpPr>
+          <p:nvPr>
+            <p:ph type="hdr" sz="quarter"/>
+          </p:nvPr>
+        </p:nvSpPr>
+        <p:spPr>
+          <a:xfrm>
+            <a:off x="0" y="0"/>
+            <a:ext cx="2971800" cy="458788"/>
+          </a:xfrm>
+          <a:prstGeom prst="rect">
+            <a:avLst/>
+          </a:prstGeom>
+        </p:spPr>
+        <p:txBody>
+          <a:bodyPr vert="horz" lIns="91440" tIns="45720" rIns="91440" bIns="45720" rtlCol="0"/>
+          <a:lstStyle>
+            <a:lvl1pPr algn="l">
+              <a:defRPr sz="1200"/>
+            </a:lvl1pPr>
+          </a:lstStyle>
+          <a:p>
+            <a:endParaRPr lang="ko-KR" altLang="en-US"/>
+          </a:p>
+        </p:txBody>
+      </p:sp>
+      <p:sp>
+        <p:nvSpPr>
+          <p:cNvPr id="3" name="날짜 개체 틀 2"/>
+          <p:cNvSpPr>
+            <a:spLocks noGrp="1"/>
+          </p:cNvSpPr>
+          <p:nvPr>
+            <p:ph type="dt" idx="1"/>
+          </p:nvPr>
+        </p:nvSpPr>
+        <p:spPr>
+          <a:xfrm>
+            <a:off x="3884613" y="0"/>
+            <a:ext cx="2971800" cy="458788"/>
+          </a:xfrm>
+          <a:prstGeom prst="rect">
+            <a:avLst/>
+          </a:prstGeom>
+        </p:spPr>
+        <p:txBody>
+          <a:bodyPr vert="horz" lIns="91440" tIns="45720" rIns="91440" bIns="45720" rtlCol="0"/>
+          <a:lstStyle>
+            <a:lvl1pPr algn="r">
+              <a:defRPr sz="1200"/>
+            </a:lvl1pPr>
+          </a:lstStyle>
+          <a:p>
+            <a:fld id="{B75627F0-38CB-4CC0-9A1E-8A834E88F0A6}" type="datetimeFigureOut">
+              <a:rPr lang="ko-KR" altLang="en-US" smtClean="0"/>
+              <a:t>2026-02-26</a:t>
+            </a:fld>
+            <a:endParaRPr lang="ko-KR" altLang="en-US"/>
+          </a:p>
+        </p:txBody>
+      </p:sp>
+      <p:sp>
+        <p:nvSpPr>
+          <p:cNvPr id="4" name="슬라이드 이미지 개체 틀 3"/>
+          <p:cNvSpPr>
+            <a:spLocks noGrp="1" noRot="1" noChangeAspect="1"/>
+          </p:cNvSpPr>
+          <p:nvPr>
+            <p:ph type="sldImg" idx="2"/>
+          </p:nvPr>
+        </p:nvSpPr>
+        <p:spPr>
+          <a:xfrm>
+            <a:off x="2908300" y="1143000"/>
+            <a:ext cx="1041400" cy="3086100"/>
+          </a:xfrm>
+          <a:prstGeom prst="rect">
+            <a:avLst/>
+          </a:prstGeom>
+          <a:noFill/>
+          <a:ln w="12700">
+            <a:solidFill>
+              <a:prstClr val="black"/>
+            </a:solidFill>
+          </a:ln>
+        </p:spPr>
+        <p:txBody>
+          <a:bodyPr vert="horz" lIns="91440" tIns="45720" rIns="91440" bIns="45720" rtlCol="0" anchor="ctr"/>
+          <a:lstStyle/>
+          <a:p>
+            <a:endParaRPr lang="ko-KR" altLang="en-US"/>
+          </a:p>
+        </p:txBody>
+      </p:sp>
+      <p:sp>
+        <p:nvSpPr>
+          <p:cNvPr id="5" name="슬라이드 노트 개체 틀 4"/>
+          <p:cNvSpPr>
+            <a:spLocks noGrp="1"/>
+          </p:cNvSpPr>
+          <p:nvPr>
+            <p:ph type="body" sz="quarter" idx="3"/>
+          </p:nvPr>
+        </p:nvSpPr>
+        <p:spPr>
+          <a:xfrm>
+            <a:off x="685800" y="4400550"/>
+            <a:ext cx="5486400" cy="3600450"/>
+          </a:xfrm>
+          <a:prstGeom prst="rect">
+            <a:avLst/>
+          </a:prstGeom>
+        </p:spPr>
+        <p:txBody>
+          <a:bodyPr vert="horz" lIns="91440" tIns="45720" rIns="91440" bIns="45720" rtlCol="0"/>
+          <a:lstStyle/>
+          <a:p>
+            <a:pPr lvl="0"/>
+            <a:r>
+              <a:rPr lang="ko-KR" altLang="en-US"/>
+              <a:t>마스터 텍스트 스타일을 편집하려면 클릭</a:t>
+            </a:r>
+          </a:p>
+          <a:p>
+            <a:pPr lvl="1"/>
+            <a:r>
+              <a:rPr lang="ko-KR" altLang="en-US"/>
+              <a:t>두 번째 수준</a:t>
+            </a:r>
+          </a:p>
+          <a:p>
+            <a:pPr lvl="2"/>
+            <a:r>
+              <a:rPr lang="ko-KR" altLang="en-US"/>
+              <a:t>세 번째 수준</a:t>
+            </a:r>
+          </a:p>
+          <a:p>
+            <a:pPr lvl="3"/>
+            <a:r>
+              <a:rPr lang="ko-KR" altLang="en-US"/>
+              <a:t>네 번째 수준</a:t>
+            </a:r>
+          </a:p>
+          <a:p>
+            <a:pPr lvl="4"/>
+            <a:r>
+              <a:rPr lang="ko-KR" altLang="en-US"/>
+              <a:t>다섯 번째 수준</a:t>
+            </a:r>
+          </a:p>
+        </p:txBody>
+      </p:sp>
+      <p:sp>
+        <p:nvSpPr>
+          <p:cNvPr id="6" name="바닥글 개체 틀 5"/>
+          <p:cNvSpPr>
+            <a:spLocks noGrp="1"/>
+          </p:cNvSpPr>
+          <p:nvPr>
+            <p:ph type="ftr" sz="quarter" idx="4"/>
+          </p:nvPr>
+        </p:nvSpPr>
+        <p:spPr>
+          <a:xfrm>
+            <a:off x="0" y="8685213"/>
+            <a:ext cx="2971800" cy="458787"/>
+          </a:xfrm>
+          <a:prstGeom prst="rect">
+            <a:avLst/>
+          </a:prstGeom>
+        </p:spPr>
+        <p:txBody>
+          <a:bodyPr vert="horz" lIns="91440" tIns="45720" rIns="91440" bIns="45720" rtlCol="0" anchor="b"/>
+          <a:lstStyle>
+            <a:lvl1pPr algn="l">
+              <a:defRPr sz="1200"/>
+            </a:lvl1pPr>
+          </a:lstStyle>
+          <a:p>
+            <a:endParaRPr lang="ko-KR" altLang="en-US"/>
+          </a:p>
+        </p:txBody>
+      </p:sp>
+      <p:sp>
+        <p:nvSpPr>
+          <p:cNvPr id="7" name="슬라이드 번호 개체 틀 6"/>
+          <p:cNvSpPr>
+            <a:spLocks noGrp="1"/>
+          </p:cNvSpPr>
+          <p:nvPr>
+            <p:ph type="sldNum" sz="quarter" idx="5"/>
+          </p:nvPr>
+        </p:nvSpPr>
+        <p:spPr>
+          <a:xfrm>
+            <a:off x="3884613" y="8685213"/>
+            <a:ext cx="2971800" cy="458787"/>
+          </a:xfrm>
+          <a:prstGeom prst="rect">
+            <a:avLst/>
+          </a:prstGeom>
+        </p:spPr>
+        <p:txBody>
+          <a:bodyPr vert="horz" lIns="91440" tIns="45720" rIns="91440" bIns="45720" rtlCol="0" anchor="b"/>
+          <a:lstStyle>
+            <a:lvl1pPr algn="r">
+              <a:defRPr sz="1200"/>
+            </a:lvl1pPr>
+          </a:lstStyle>
+          <a:p>
+            <a:fld id="{7575EDA1-D74C-47EC-920D-63BE5821734A}" type="slidenum">
+              <a:rPr lang="ko-KR" altLang="en-US" smtClean="0"/>
+              <a:t>‹#›</a:t>
+            </a:fld>
+            <a:endParaRPr lang="ko-KR" altLang="en-US"/>
+          </a:p>
+        </p:txBody>
+      </p:sp>
+    </p:spTree>
+    <p:extLst>
+      <p:ext uri="{BB962C8B-B14F-4D97-AF65-F5344CB8AC3E}">
+        <p14:creationId xmlns:p14="http://schemas.microsoft.com/office/powerpoint/2010/main" val="2583759879"/>
+      </p:ext>
+    </p:extLst>
+  </p:cSld>
+  <p:clrMap bg1="lt1" tx1="dk1" bg2="lt2" tx2="dk2" accent1="accent1" accent2="accent2" accent3="accent3" accent4="accent4" accent5="accent5" accent6="accent6" hlink="hlink" folHlink="folHlink"/>
+  <p:notesStyle>
+    <a:lvl1pPr marL="0" algn="l" defTabSz="684246" rtl="0" eaLnBrk="1" latinLnBrk="1" hangingPunct="1">
+      <a:defRPr sz="898" kern="1200">
+        <a:solidFill>
+          <a:schemeClr val="tx1"/>
+        </a:solidFill>
+        <a:latin typeface="+mn-lt"/>
+        <a:ea typeface="+mn-ea"/>
+        <a:cs typeface="+mn-cs"/>
+      </a:defRPr>
+    </a:lvl1pPr>
+    <a:lvl2pPr marL="342123" algn="l" defTabSz="684246" rtl="0" eaLnBrk="1" latinLnBrk="1" hangingPunct="1">
+      <a:defRPr sz="898" kern="1200">
+        <a:solidFill>
+          <a:schemeClr val="tx1"/>
+        </a:solidFill>
+        <a:latin typeface="+mn-lt"/>
+        <a:ea typeface="+mn-ea"/>
+        <a:cs typeface="+mn-cs"/>
+      </a:defRPr>
+    </a:lvl2pPr>
+    <a:lvl3pPr marL="684246" algn="l" defTabSz="684246" rtl="0" eaLnBrk="1" latinLnBrk="1" hangingPunct="1">
+      <a:defRPr sz="898" kern="1200">
+        <a:solidFill>
+          <a:schemeClr val="tx1"/>
+        </a:solidFill>
+        <a:latin typeface="+mn-lt"/>
+        <a:ea typeface="+mn-ea"/>
+        <a:cs typeface="+mn-cs"/>
+      </a:defRPr>
+    </a:lvl3pPr>
+    <a:lvl4pPr marL="1026368" algn="l" defTabSz="684246" rtl="0" eaLnBrk="1" latinLnBrk="1" hangingPunct="1">
+      <a:defRPr sz="898" kern="1200">
+        <a:solidFill>
+          <a:schemeClr val="tx1"/>
+        </a:solidFill>
+        <a:latin typeface="+mn-lt"/>
+        <a:ea typeface="+mn-ea"/>
+        <a:cs typeface="+mn-cs"/>
+      </a:defRPr>
+    </a:lvl4pPr>
+    <a:lvl5pPr marL="1368491" algn="l" defTabSz="684246" rtl="0" eaLnBrk="1" latinLnBrk="1" hangingPunct="1">
+      <a:defRPr sz="898" kern="1200">
+        <a:solidFill>
+          <a:schemeClr val="tx1"/>
+        </a:solidFill>
+        <a:latin typeface="+mn-lt"/>
+        <a:ea typeface="+mn-ea"/>
+        <a:cs typeface="+mn-cs"/>
+      </a:defRPr>
+    </a:lvl5pPr>
+    <a:lvl6pPr marL="1710614" algn="l" defTabSz="684246" rtl="0" eaLnBrk="1" latinLnBrk="1" hangingPunct="1">
+      <a:defRPr sz="898" kern="1200">
+        <a:solidFill>
+          <a:schemeClr val="tx1"/>
+        </a:solidFill>
+        <a:latin typeface="+mn-lt"/>
+        <a:ea typeface="+mn-ea"/>
+        <a:cs typeface="+mn-cs"/>
+      </a:defRPr>
+    </a:lvl6pPr>
+    <a:lvl7pPr marL="2052737" algn="l" defTabSz="684246" rtl="0" eaLnBrk="1" latinLnBrk="1" hangingPunct="1">
+      <a:defRPr sz="898" kern="1200">
+        <a:solidFill>
+          <a:schemeClr val="tx1"/>
+        </a:solidFill>
+        <a:latin typeface="+mn-lt"/>
+        <a:ea typeface="+mn-ea"/>
+        <a:cs typeface="+mn-cs"/>
+      </a:defRPr>
+    </a:lvl7pPr>
+    <a:lvl8pPr marL="2394859" algn="l" defTabSz="684246" rtl="0" eaLnBrk="1" latinLnBrk="1" hangingPunct="1">
+      <a:defRPr sz="898" kern="1200">
+        <a:solidFill>
+          <a:schemeClr val="tx1"/>
+        </a:solidFill>
+        <a:latin typeface="+mn-lt"/>
+        <a:ea typeface="+mn-ea"/>
+        <a:cs typeface="+mn-cs"/>
+      </a:defRPr>
+    </a:lvl8pPr>
+    <a:lvl9pPr marL="2736982" algn="l" defTabSz="684246" rtl="0" eaLnBrk="1" latinLnBrk="1" hangingPunct="1">
+      <a:defRPr sz="898" kern="1200">
+        <a:solidFill>
+          <a:schemeClr val="tx1"/>
+        </a:solidFill>
+        <a:latin typeface="+mn-lt"/>
+        <a:ea typeface="+mn-ea"/>
+        <a:cs typeface="+mn-cs"/>
+      </a:defRPr>
+    </a:lvl9pPr>
+  </p:notesStyle>
+</p:notesMaster>
+</file>
+
+<file path=ppt/notesSlides/notesSlide1.xml><?xml version="1.0" encoding="utf-8"?>
+<p:notes xmlns:a="http://schemas.openxmlformats.org/drawingml/2006/main" xmlns:r="http://schemas.openxmlformats.org/officeDocument/2006/relationships" xmlns:p="http://schemas.openxmlformats.org/presentationml/2006/main">
+  <p:cSld>
+    <p:spTree>
+      <p:nvGrpSpPr>
+        <p:cNvPr id="1" name="">
+          <a:extLst>
+            <a:ext uri="{FF2B5EF4-FFF2-40B4-BE49-F238E27FC236}">
+              <a16:creationId xmlns:a16="http://schemas.microsoft.com/office/drawing/2014/main" id="{4F9A6D86-7953-227D-6496-6B7894398476}"/>
+            </a:ext>
+          </a:extLst>
+        </p:cNvPr>
+        <p:cNvGrpSpPr/>
+        <p:nvPr/>
+      </p:nvGrpSpPr>
+      <p:grpSpPr>
+        <a:xfrm>
+          <a:off x="0" y="0"/>
+          <a:ext cx="0" cy="0"/>
+          <a:chOff x="0" y="0"/>
+          <a:chExt cx="0" cy="0"/>
+        </a:xfrm>
+      </p:grpSpPr>
+      <p:sp>
+        <p:nvSpPr>
+          <p:cNvPr id="2" name="슬라이드 이미지 개체 틀 1">
+            <a:extLst>
+              <a:ext uri="{FF2B5EF4-FFF2-40B4-BE49-F238E27FC236}">
+                <a16:creationId xmlns:a16="http://schemas.microsoft.com/office/drawing/2014/main" id="{6144C445-C9EC-F75F-C0DB-F8F8B9BD97B0}"/>
+              </a:ext>
+            </a:extLst>
+          </p:cNvPr>
+          <p:cNvSpPr>
+            <a:spLocks noGrp="1" noRot="1" noChangeAspect="1"/>
+          </p:cNvSpPr>
+          <p:nvPr>
+            <p:ph type="sldImg"/>
+          </p:nvPr>
+        </p:nvSpPr>
+        <p:spPr/>
+      </p:sp>
+      <p:sp>
+        <p:nvSpPr>
+          <p:cNvPr id="3" name="슬라이드 노트 개체 틀 2">
+            <a:extLst>
+              <a:ext uri="{FF2B5EF4-FFF2-40B4-BE49-F238E27FC236}">
+                <a16:creationId xmlns:a16="http://schemas.microsoft.com/office/drawing/2014/main" id="{DEB02337-0DF1-627E-BFB9-9855C1D3EEE8}"/>
+              </a:ext>
+            </a:extLst>
+          </p:cNvPr>
+          <p:cNvSpPr>
+            <a:spLocks noGrp="1"/>
+          </p:cNvSpPr>
+          <p:nvPr>
+            <p:ph type="body" idx="1"/>
+          </p:nvPr>
+        </p:nvSpPr>
+        <p:spPr/>
+        <p:txBody>
+          <a:bodyPr/>
+          <a:lstStyle/>
+          <a:p>
+            <a:endParaRPr lang="ko-KR" altLang="en-US"/>
+          </a:p>
+        </p:txBody>
+      </p:sp>
+      <p:sp>
+        <p:nvSpPr>
+          <p:cNvPr id="4" name="슬라이드 번호 개체 틀 3">
+            <a:extLst>
+              <a:ext uri="{FF2B5EF4-FFF2-40B4-BE49-F238E27FC236}">
+                <a16:creationId xmlns:a16="http://schemas.microsoft.com/office/drawing/2014/main" id="{AEB81BCF-E950-D535-341E-6A84F07E7B37}"/>
+              </a:ext>
+            </a:extLst>
+          </p:cNvPr>
+          <p:cNvSpPr>
+            <a:spLocks noGrp="1"/>
+          </p:cNvSpPr>
+          <p:nvPr>
+            <p:ph type="sldNum" sz="quarter" idx="5"/>
+          </p:nvPr>
+        </p:nvSpPr>
+        <p:spPr/>
+        <p:txBody>
+          <a:bodyPr/>
+          <a:lstStyle/>
+          <a:p>
+            <a:fld id="{7575EDA1-D74C-47EC-920D-63BE5821734A}" type="slidenum">
+              <a:rPr lang="ko-KR" altLang="en-US" smtClean="0"/>
+              <a:t>3</a:t>
+            </a:fld>
+            <a:endParaRPr lang="ko-KR" altLang="en-US"/>
+          </a:p>
+        </p:txBody>
+      </p:sp>
+    </p:spTree>
+    <p:extLst>
+      <p:ext uri="{BB962C8B-B14F-4D97-AF65-F5344CB8AC3E}">
+        <p14:creationId xmlns:p14="http://schemas.microsoft.com/office/powerpoint/2010/main" val="618243874"/>
+      </p:ext>
+    </p:extLst>
+  </p:cSld>
+  <p:clrMapOvr>
+    <a:masterClrMapping/>
+  </p:clrMapOvr>
+</p:notes>
+</file>
+
+<file path=ppt/notesSlides/notesSlide2.xml><?xml version="1.0" encoding="utf-8"?>
+<p:notes xmlns:a="http://schemas.openxmlformats.org/drawingml/2006/main" xmlns:r="http://schemas.openxmlformats.org/officeDocument/2006/relationships" xmlns:p="http://schemas.openxmlformats.org/presentationml/2006/main">
+  <p:cSld>
+    <p:spTree>
+      <p:nvGrpSpPr>
+        <p:cNvPr id="1" name="">
+          <a:extLst>
+            <a:ext uri="{FF2B5EF4-FFF2-40B4-BE49-F238E27FC236}">
+              <a16:creationId xmlns:a16="http://schemas.microsoft.com/office/drawing/2014/main" id="{9C067896-8CE6-0F63-9B41-3E19A833C250}"/>
+            </a:ext>
+          </a:extLst>
+        </p:cNvPr>
+        <p:cNvGrpSpPr/>
+        <p:nvPr/>
+      </p:nvGrpSpPr>
+      <p:grpSpPr>
+        <a:xfrm>
+          <a:off x="0" y="0"/>
+          <a:ext cx="0" cy="0"/>
+          <a:chOff x="0" y="0"/>
+          <a:chExt cx="0" cy="0"/>
+        </a:xfrm>
+      </p:grpSpPr>
+      <p:sp>
+        <p:nvSpPr>
+          <p:cNvPr id="2" name="슬라이드 이미지 개체 틀 1">
+            <a:extLst>
+              <a:ext uri="{FF2B5EF4-FFF2-40B4-BE49-F238E27FC236}">
+                <a16:creationId xmlns:a16="http://schemas.microsoft.com/office/drawing/2014/main" id="{7A857447-82CB-814C-317B-73B4D7CE0B80}"/>
+              </a:ext>
+            </a:extLst>
+          </p:cNvPr>
+          <p:cNvSpPr>
+            <a:spLocks noGrp="1" noRot="1" noChangeAspect="1"/>
+          </p:cNvSpPr>
+          <p:nvPr>
+            <p:ph type="sldImg"/>
+          </p:nvPr>
+        </p:nvSpPr>
+        <p:spPr/>
+      </p:sp>
+      <p:sp>
+        <p:nvSpPr>
+          <p:cNvPr id="3" name="슬라이드 노트 개체 틀 2">
+            <a:extLst>
+              <a:ext uri="{FF2B5EF4-FFF2-40B4-BE49-F238E27FC236}">
+                <a16:creationId xmlns:a16="http://schemas.microsoft.com/office/drawing/2014/main" id="{91050BAF-39EA-CF36-7B0A-527D4A201811}"/>
+              </a:ext>
+            </a:extLst>
+          </p:cNvPr>
+          <p:cNvSpPr>
+            <a:spLocks noGrp="1"/>
+          </p:cNvSpPr>
+          <p:nvPr>
+            <p:ph type="body" idx="1"/>
+          </p:nvPr>
+        </p:nvSpPr>
+        <p:spPr/>
+        <p:txBody>
+          <a:bodyPr/>
+          <a:lstStyle/>
+          <a:p>
+            <a:pPr marL="0" marR="0" lvl="0" indent="0" algn="l" defTabSz="684246" rtl="0" eaLnBrk="1" fontAlgn="auto" latinLnBrk="1" hangingPunct="1">
+              <a:lnSpc>
+                <a:spcPct val="100000"/>
+              </a:lnSpc>
+              <a:spcBef>
+                <a:spcPts val="0"/>
+              </a:spcBef>
+              <a:spcAft>
+                <a:spcPts val="0"/>
+              </a:spcAft>
+              <a:buClrTx/>
+              <a:buSzTx/>
+              <a:buFontTx/>
+              <a:buNone/>
+              <a:tabLst/>
+              <a:defRPr/>
+            </a:pPr>
+            <a:r>
+              <a:rPr lang="ko-KR" altLang="en-US" sz="900" spc="-150">
+                <a:solidFill>
+                  <a:schemeClr val="tx1"/>
+                </a:solidFill>
+                <a:latin typeface="페이퍼로지 1 Thin" pitchFamily="2" charset="-127"/>
+                <a:ea typeface="페이퍼로지 1 Thin" pitchFamily="2" charset="-127"/>
+              </a:rPr>
+              <a:t>이미지 출처 </a:t>
+            </a:r>
+            <a:r>
+              <a:rPr lang="en-US" altLang="ko-KR" sz="900" spc="-150">
+                <a:solidFill>
+                  <a:schemeClr val="tx1"/>
+                </a:solidFill>
+                <a:latin typeface="페이퍼로지 1 Thin" pitchFamily="2" charset="-127"/>
+                <a:ea typeface="페이퍼로지 1 Thin" pitchFamily="2" charset="-127"/>
+              </a:rPr>
+              <a:t>- Vecteezy.com </a:t>
+            </a:r>
+            <a:endParaRPr lang="ko-KR" altLang="en-US" sz="1600" spc="-150">
+              <a:solidFill>
+                <a:schemeClr val="tx1"/>
+              </a:solidFill>
+              <a:latin typeface="페이퍼로지 1 Thin" pitchFamily="2" charset="-127"/>
+              <a:ea typeface="페이퍼로지 1 Thin" pitchFamily="2" charset="-127"/>
+            </a:endParaRPr>
+          </a:p>
+        </p:txBody>
+      </p:sp>
+      <p:sp>
+        <p:nvSpPr>
+          <p:cNvPr id="4" name="슬라이드 번호 개체 틀 3">
+            <a:extLst>
+              <a:ext uri="{FF2B5EF4-FFF2-40B4-BE49-F238E27FC236}">
+                <a16:creationId xmlns:a16="http://schemas.microsoft.com/office/drawing/2014/main" id="{F28C924F-4115-EF2C-AB65-646529DEF4F2}"/>
+              </a:ext>
+            </a:extLst>
+          </p:cNvPr>
+          <p:cNvSpPr>
+            <a:spLocks noGrp="1"/>
+          </p:cNvSpPr>
+          <p:nvPr>
+            <p:ph type="sldNum" sz="quarter" idx="5"/>
+          </p:nvPr>
+        </p:nvSpPr>
+        <p:spPr/>
+        <p:txBody>
+          <a:bodyPr/>
+          <a:lstStyle/>
+          <a:p>
+            <a:fld id="{7575EDA1-D74C-47EC-920D-63BE5821734A}" type="slidenum">
+              <a:rPr lang="ko-KR" altLang="en-US" smtClean="0"/>
+              <a:t>4</a:t>
+            </a:fld>
+            <a:endParaRPr lang="ko-KR" altLang="en-US"/>
+          </a:p>
+        </p:txBody>
+      </p:sp>
+    </p:spTree>
+    <p:extLst>
+      <p:ext uri="{BB962C8B-B14F-4D97-AF65-F5344CB8AC3E}">
+        <p14:creationId xmlns:p14="http://schemas.microsoft.com/office/powerpoint/2010/main" val="4228050750"/>
+      </p:ext>
+    </p:extLst>
+  </p:cSld>
+  <p:clrMapOvr>
+    <a:masterClrMapping/>
+  </p:clrMapOvr>
+</p:notes>
 </file>
 
 <file path=ppt/slideLayouts/slideLayout1.xml><?xml version="1.0" encoding="utf-8"?>
@@ -153,15 +766,15 @@
         </p:nvSpPr>
         <p:spPr>
           <a:xfrm>
-            <a:off x="514350" y="1995312"/>
-            <a:ext cx="5829300" cy="4244622"/>
+            <a:off x="270034" y="1743820"/>
+            <a:ext cx="3060383" cy="3709623"/>
           </a:xfrm>
         </p:spPr>
         <p:txBody>
           <a:bodyPr anchor="b"/>
           <a:lstStyle>
             <a:lvl1pPr algn="ctr">
-              <a:defRPr sz="4500"/>
+              <a:defRPr sz="2363"/>
             </a:lvl1pPr>
           </a:lstStyle>
           <a:p>
@@ -185,8 +798,8 @@
         </p:nvSpPr>
         <p:spPr>
           <a:xfrm>
-            <a:off x="857250" y="6403623"/>
-            <a:ext cx="5143500" cy="2943577"/>
+            <a:off x="450056" y="5596500"/>
+            <a:ext cx="2700338" cy="2572564"/>
           </a:xfrm>
         </p:spPr>
         <p:txBody>
@@ -194,39 +807,39 @@
           <a:lstStyle>
             <a:lvl1pPr marL="0" indent="0" algn="ctr">
               <a:buNone/>
-              <a:defRPr sz="1800"/>
+              <a:defRPr sz="945"/>
             </a:lvl1pPr>
-            <a:lvl2pPr marL="342900" indent="0" algn="ctr">
-              <a:buNone/>
-              <a:defRPr sz="1500"/>
+            <a:lvl2pPr marL="180045" indent="0" algn="ctr">
+              <a:buNone/>
+              <a:defRPr sz="788"/>
             </a:lvl2pPr>
-            <a:lvl3pPr marL="685800" indent="0" algn="ctr">
-              <a:buNone/>
-              <a:defRPr sz="1350"/>
+            <a:lvl3pPr marL="360091" indent="0" algn="ctr">
+              <a:buNone/>
+              <a:defRPr sz="709"/>
             </a:lvl3pPr>
-            <a:lvl4pPr marL="1028700" indent="0" algn="ctr">
-              <a:buNone/>
-              <a:defRPr sz="1200"/>
+            <a:lvl4pPr marL="540136" indent="0" algn="ctr">
+              <a:buNone/>
+              <a:defRPr sz="630"/>
             </a:lvl4pPr>
-            <a:lvl5pPr marL="1371600" indent="0" algn="ctr">
-              <a:buNone/>
-              <a:defRPr sz="1200"/>
+            <a:lvl5pPr marL="720181" indent="0" algn="ctr">
+              <a:buNone/>
+              <a:defRPr sz="630"/>
             </a:lvl5pPr>
-            <a:lvl6pPr marL="1714500" indent="0" algn="ctr">
-              <a:buNone/>
-              <a:defRPr sz="1200"/>
+            <a:lvl6pPr marL="900227" indent="0" algn="ctr">
+              <a:buNone/>
+              <a:defRPr sz="630"/>
             </a:lvl6pPr>
-            <a:lvl7pPr marL="2057400" indent="0" algn="ctr">
-              <a:buNone/>
-              <a:defRPr sz="1200"/>
+            <a:lvl7pPr marL="1080272" indent="0" algn="ctr">
+              <a:buNone/>
+              <a:defRPr sz="630"/>
             </a:lvl7pPr>
-            <a:lvl8pPr marL="2400300" indent="0" algn="ctr">
-              <a:buNone/>
-              <a:defRPr sz="1200"/>
+            <a:lvl8pPr marL="1260318" indent="0" algn="ctr">
+              <a:buNone/>
+              <a:defRPr sz="630"/>
             </a:lvl8pPr>
-            <a:lvl9pPr marL="2743200" indent="0" algn="ctr">
-              <a:buNone/>
-              <a:defRPr sz="1200"/>
+            <a:lvl9pPr marL="1440363" indent="0" algn="ctr">
+              <a:buNone/>
+              <a:defRPr sz="630"/>
             </a:lvl9pPr>
           </a:lstStyle>
           <a:p>
@@ -255,7 +868,7 @@
           <a:p>
             <a:fld id="{5802A5F5-DD2A-4576-86B6-34DB5722830F}" type="datetimeFigureOut">
               <a:rPr lang="ko-KR" altLang="en-US" smtClean="0"/>
-              <a:t>2025-11-14</a:t>
+              <a:t>2026-02-26</a:t>
             </a:fld>
             <a:endParaRPr lang="ko-KR" altLang="en-US"/>
           </a:p>
@@ -306,7 +919,7 @@
     </p:spTree>
     <p:extLst>
       <p:ext uri="{BB962C8B-B14F-4D97-AF65-F5344CB8AC3E}">
-        <p14:creationId xmlns:p14="http://schemas.microsoft.com/office/powerpoint/2010/main" val="3012412576"/>
+        <p14:creationId xmlns:p14="http://schemas.microsoft.com/office/powerpoint/2010/main" val="3670269635"/>
       </p:ext>
     </p:extLst>
   </p:cSld>
@@ -425,7 +1038,7 @@
           <a:p>
             <a:fld id="{5802A5F5-DD2A-4576-86B6-34DB5722830F}" type="datetimeFigureOut">
               <a:rPr lang="ko-KR" altLang="en-US" smtClean="0"/>
-              <a:t>2025-11-14</a:t>
+              <a:t>2026-02-26</a:t>
             </a:fld>
             <a:endParaRPr lang="ko-KR" altLang="en-US"/>
           </a:p>
@@ -476,7 +1089,7 @@
     </p:spTree>
     <p:extLst>
       <p:ext uri="{BB962C8B-B14F-4D97-AF65-F5344CB8AC3E}">
-        <p14:creationId xmlns:p14="http://schemas.microsoft.com/office/powerpoint/2010/main" val="2611342830"/>
+        <p14:creationId xmlns:p14="http://schemas.microsoft.com/office/powerpoint/2010/main" val="2742233452"/>
       </p:ext>
     </p:extLst>
   </p:cSld>
@@ -515,8 +1128,8 @@
         </p:nvSpPr>
         <p:spPr>
           <a:xfrm>
-            <a:off x="4907757" y="649111"/>
-            <a:ext cx="1478756" cy="10332156"/>
+            <a:off x="2576572" y="567296"/>
+            <a:ext cx="776347" cy="9029874"/>
           </a:xfrm>
         </p:spPr>
         <p:txBody>
@@ -543,8 +1156,8 @@
         </p:nvSpPr>
         <p:spPr>
           <a:xfrm>
-            <a:off x="471488" y="649111"/>
-            <a:ext cx="4350544" cy="10332156"/>
+            <a:off x="247531" y="567296"/>
+            <a:ext cx="2284035" cy="9029874"/>
           </a:xfrm>
         </p:spPr>
         <p:txBody>
@@ -605,7 +1218,7 @@
           <a:p>
             <a:fld id="{5802A5F5-DD2A-4576-86B6-34DB5722830F}" type="datetimeFigureOut">
               <a:rPr lang="ko-KR" altLang="en-US" smtClean="0"/>
-              <a:t>2025-11-14</a:t>
+              <a:t>2026-02-26</a:t>
             </a:fld>
             <a:endParaRPr lang="ko-KR" altLang="en-US"/>
           </a:p>
@@ -656,7 +1269,7 @@
     </p:spTree>
     <p:extLst>
       <p:ext uri="{BB962C8B-B14F-4D97-AF65-F5344CB8AC3E}">
-        <p14:creationId xmlns:p14="http://schemas.microsoft.com/office/powerpoint/2010/main" val="2461266941"/>
+        <p14:creationId xmlns:p14="http://schemas.microsoft.com/office/powerpoint/2010/main" val="4215971368"/>
       </p:ext>
     </p:extLst>
   </p:cSld>
@@ -775,7 +1388,7 @@
           <a:p>
             <a:fld id="{5802A5F5-DD2A-4576-86B6-34DB5722830F}" type="datetimeFigureOut">
               <a:rPr lang="ko-KR" altLang="en-US" smtClean="0"/>
-              <a:t>2025-11-14</a:t>
+              <a:t>2026-02-26</a:t>
             </a:fld>
             <a:endParaRPr lang="ko-KR" altLang="en-US"/>
           </a:p>
@@ -826,7 +1439,7 @@
     </p:spTree>
     <p:extLst>
       <p:ext uri="{BB962C8B-B14F-4D97-AF65-F5344CB8AC3E}">
-        <p14:creationId xmlns:p14="http://schemas.microsoft.com/office/powerpoint/2010/main" val="2851853871"/>
+        <p14:creationId xmlns:p14="http://schemas.microsoft.com/office/powerpoint/2010/main" val="3981807874"/>
       </p:ext>
     </p:extLst>
   </p:cSld>
@@ -865,15 +1478,15 @@
         </p:nvSpPr>
         <p:spPr>
           <a:xfrm>
-            <a:off x="467916" y="3039537"/>
-            <a:ext cx="5915025" cy="5071532"/>
+            <a:off x="245656" y="2656429"/>
+            <a:ext cx="3105388" cy="4432308"/>
           </a:xfrm>
         </p:spPr>
         <p:txBody>
           <a:bodyPr anchor="b"/>
           <a:lstStyle>
             <a:lvl1pPr>
-              <a:defRPr sz="4500"/>
+              <a:defRPr sz="2363"/>
             </a:lvl1pPr>
           </a:lstStyle>
           <a:p>
@@ -897,8 +1510,8 @@
         </p:nvSpPr>
         <p:spPr>
           <a:xfrm>
-            <a:off x="467916" y="8159048"/>
-            <a:ext cx="5915025" cy="2666999"/>
+            <a:off x="245656" y="7130668"/>
+            <a:ext cx="3105388" cy="2330846"/>
           </a:xfrm>
         </p:spPr>
         <p:txBody>
@@ -906,15 +1519,15 @@
           <a:lstStyle>
             <a:lvl1pPr marL="0" indent="0">
               <a:buNone/>
-              <a:defRPr sz="1800">
+              <a:defRPr sz="945">
                 <a:solidFill>
                   <a:schemeClr val="tx1"/>
                 </a:solidFill>
               </a:defRPr>
             </a:lvl1pPr>
-            <a:lvl2pPr marL="342900" indent="0">
-              <a:buNone/>
-              <a:defRPr sz="1500">
+            <a:lvl2pPr marL="180045" indent="0">
+              <a:buNone/>
+              <a:defRPr sz="788">
                 <a:solidFill>
                   <a:schemeClr val="tx1">
                     <a:tint val="75000"/>
@@ -922,9 +1535,9 @@
                 </a:solidFill>
               </a:defRPr>
             </a:lvl2pPr>
-            <a:lvl3pPr marL="685800" indent="0">
-              <a:buNone/>
-              <a:defRPr sz="1350">
+            <a:lvl3pPr marL="360091" indent="0">
+              <a:buNone/>
+              <a:defRPr sz="709">
                 <a:solidFill>
                   <a:schemeClr val="tx1">
                     <a:tint val="75000"/>
@@ -932,9 +1545,9 @@
                 </a:solidFill>
               </a:defRPr>
             </a:lvl3pPr>
-            <a:lvl4pPr marL="1028700" indent="0">
-              <a:buNone/>
-              <a:defRPr sz="1200">
+            <a:lvl4pPr marL="540136" indent="0">
+              <a:buNone/>
+              <a:defRPr sz="630">
                 <a:solidFill>
                   <a:schemeClr val="tx1">
                     <a:tint val="75000"/>
@@ -942,9 +1555,9 @@
                 </a:solidFill>
               </a:defRPr>
             </a:lvl4pPr>
-            <a:lvl5pPr marL="1371600" indent="0">
-              <a:buNone/>
-              <a:defRPr sz="1200">
+            <a:lvl5pPr marL="720181" indent="0">
+              <a:buNone/>
+              <a:defRPr sz="630">
                 <a:solidFill>
                   <a:schemeClr val="tx1">
                     <a:tint val="75000"/>
@@ -952,9 +1565,9 @@
                 </a:solidFill>
               </a:defRPr>
             </a:lvl5pPr>
-            <a:lvl6pPr marL="1714500" indent="0">
-              <a:buNone/>
-              <a:defRPr sz="1200">
+            <a:lvl6pPr marL="900227" indent="0">
+              <a:buNone/>
+              <a:defRPr sz="630">
                 <a:solidFill>
                   <a:schemeClr val="tx1">
                     <a:tint val="75000"/>
@@ -962,9 +1575,9 @@
                 </a:solidFill>
               </a:defRPr>
             </a:lvl6pPr>
-            <a:lvl7pPr marL="2057400" indent="0">
-              <a:buNone/>
-              <a:defRPr sz="1200">
+            <a:lvl7pPr marL="1080272" indent="0">
+              <a:buNone/>
+              <a:defRPr sz="630">
                 <a:solidFill>
                   <a:schemeClr val="tx1">
                     <a:tint val="75000"/>
@@ -972,9 +1585,9 @@
                 </a:solidFill>
               </a:defRPr>
             </a:lvl7pPr>
-            <a:lvl8pPr marL="2400300" indent="0">
-              <a:buNone/>
-              <a:defRPr sz="1200">
+            <a:lvl8pPr marL="1260318" indent="0">
+              <a:buNone/>
+              <a:defRPr sz="630">
                 <a:solidFill>
                   <a:schemeClr val="tx1">
                     <a:tint val="75000"/>
@@ -982,9 +1595,9 @@
                 </a:solidFill>
               </a:defRPr>
             </a:lvl8pPr>
-            <a:lvl9pPr marL="2743200" indent="0">
-              <a:buNone/>
-              <a:defRPr sz="1200">
+            <a:lvl9pPr marL="1440363" indent="0">
+              <a:buNone/>
+              <a:defRPr sz="630">
                 <a:solidFill>
                   <a:schemeClr val="tx1">
                     <a:tint val="75000"/>
@@ -1019,7 +1632,7 @@
           <a:p>
             <a:fld id="{5802A5F5-DD2A-4576-86B6-34DB5722830F}" type="datetimeFigureOut">
               <a:rPr lang="ko-KR" altLang="en-US" smtClean="0"/>
-              <a:t>2025-11-14</a:t>
+              <a:t>2026-02-26</a:t>
             </a:fld>
             <a:endParaRPr lang="ko-KR" altLang="en-US"/>
           </a:p>
@@ -1070,7 +1683,7 @@
     </p:spTree>
     <p:extLst>
       <p:ext uri="{BB962C8B-B14F-4D97-AF65-F5344CB8AC3E}">
-        <p14:creationId xmlns:p14="http://schemas.microsoft.com/office/powerpoint/2010/main" val="2635855718"/>
+        <p14:creationId xmlns:p14="http://schemas.microsoft.com/office/powerpoint/2010/main" val="552375046"/>
       </p:ext>
     </p:extLst>
   </p:cSld>
@@ -1132,8 +1745,8 @@
         </p:nvSpPr>
         <p:spPr>
           <a:xfrm>
-            <a:off x="471488" y="3245556"/>
-            <a:ext cx="2914650" cy="7735712"/>
+            <a:off x="247531" y="2836480"/>
+            <a:ext cx="1530191" cy="6760690"/>
           </a:xfrm>
         </p:spPr>
         <p:txBody>
@@ -1189,8 +1802,8 @@
         </p:nvSpPr>
         <p:spPr>
           <a:xfrm>
-            <a:off x="3471863" y="3245556"/>
-            <a:ext cx="2914650" cy="7735712"/>
+            <a:off x="1822728" y="2836480"/>
+            <a:ext cx="1530191" cy="6760690"/>
           </a:xfrm>
         </p:spPr>
         <p:txBody>
@@ -1251,7 +1864,7 @@
           <a:p>
             <a:fld id="{5802A5F5-DD2A-4576-86B6-34DB5722830F}" type="datetimeFigureOut">
               <a:rPr lang="ko-KR" altLang="en-US" smtClean="0"/>
-              <a:t>2025-11-14</a:t>
+              <a:t>2026-02-26</a:t>
             </a:fld>
             <a:endParaRPr lang="ko-KR" altLang="en-US"/>
           </a:p>
@@ -1302,7 +1915,7 @@
     </p:spTree>
     <p:extLst>
       <p:ext uri="{BB962C8B-B14F-4D97-AF65-F5344CB8AC3E}">
-        <p14:creationId xmlns:p14="http://schemas.microsoft.com/office/powerpoint/2010/main" val="627676841"/>
+        <p14:creationId xmlns:p14="http://schemas.microsoft.com/office/powerpoint/2010/main" val="845063910"/>
       </p:ext>
     </p:extLst>
   </p:cSld>
@@ -1341,8 +1954,8 @@
         </p:nvSpPr>
         <p:spPr>
           <a:xfrm>
-            <a:off x="472381" y="649114"/>
-            <a:ext cx="5915025" cy="2356556"/>
+            <a:off x="248000" y="567298"/>
+            <a:ext cx="3105388" cy="2059532"/>
           </a:xfrm>
         </p:spPr>
         <p:txBody>
@@ -1369,8 +1982,8 @@
         </p:nvSpPr>
         <p:spPr>
           <a:xfrm>
-            <a:off x="472381" y="2988734"/>
-            <a:ext cx="2901255" cy="1464732"/>
+            <a:off x="248000" y="2612029"/>
+            <a:ext cx="1523159" cy="1280115"/>
           </a:xfrm>
         </p:spPr>
         <p:txBody>
@@ -1378,39 +1991,39 @@
           <a:lstStyle>
             <a:lvl1pPr marL="0" indent="0">
               <a:buNone/>
-              <a:defRPr sz="1800" b="1"/>
+              <a:defRPr sz="945" b="1"/>
             </a:lvl1pPr>
-            <a:lvl2pPr marL="342900" indent="0">
-              <a:buNone/>
-              <a:defRPr sz="1500" b="1"/>
+            <a:lvl2pPr marL="180045" indent="0">
+              <a:buNone/>
+              <a:defRPr sz="788" b="1"/>
             </a:lvl2pPr>
-            <a:lvl3pPr marL="685800" indent="0">
-              <a:buNone/>
-              <a:defRPr sz="1350" b="1"/>
+            <a:lvl3pPr marL="360091" indent="0">
+              <a:buNone/>
+              <a:defRPr sz="709" b="1"/>
             </a:lvl3pPr>
-            <a:lvl4pPr marL="1028700" indent="0">
-              <a:buNone/>
-              <a:defRPr sz="1200" b="1"/>
+            <a:lvl4pPr marL="540136" indent="0">
+              <a:buNone/>
+              <a:defRPr sz="630" b="1"/>
             </a:lvl4pPr>
-            <a:lvl5pPr marL="1371600" indent="0">
-              <a:buNone/>
-              <a:defRPr sz="1200" b="1"/>
+            <a:lvl5pPr marL="720181" indent="0">
+              <a:buNone/>
+              <a:defRPr sz="630" b="1"/>
             </a:lvl5pPr>
-            <a:lvl6pPr marL="1714500" indent="0">
-              <a:buNone/>
-              <a:defRPr sz="1200" b="1"/>
+            <a:lvl6pPr marL="900227" indent="0">
+              <a:buNone/>
+              <a:defRPr sz="630" b="1"/>
             </a:lvl6pPr>
-            <a:lvl7pPr marL="2057400" indent="0">
-              <a:buNone/>
-              <a:defRPr sz="1200" b="1"/>
+            <a:lvl7pPr marL="1080272" indent="0">
+              <a:buNone/>
+              <a:defRPr sz="630" b="1"/>
             </a:lvl7pPr>
-            <a:lvl8pPr marL="2400300" indent="0">
-              <a:buNone/>
-              <a:defRPr sz="1200" b="1"/>
+            <a:lvl8pPr marL="1260318" indent="0">
+              <a:buNone/>
+              <a:defRPr sz="630" b="1"/>
             </a:lvl8pPr>
-            <a:lvl9pPr marL="2743200" indent="0">
-              <a:buNone/>
-              <a:defRPr sz="1200" b="1"/>
+            <a:lvl9pPr marL="1440363" indent="0">
+              <a:buNone/>
+              <a:defRPr sz="630" b="1"/>
             </a:lvl9pPr>
           </a:lstStyle>
           <a:p>
@@ -1434,8 +2047,8 @@
         </p:nvSpPr>
         <p:spPr>
           <a:xfrm>
-            <a:off x="472381" y="4453467"/>
-            <a:ext cx="2901255" cy="6550379"/>
+            <a:off x="248000" y="3892144"/>
+            <a:ext cx="1523159" cy="5724758"/>
           </a:xfrm>
         </p:spPr>
         <p:txBody>
@@ -1491,8 +2104,8 @@
         </p:nvSpPr>
         <p:spPr>
           <a:xfrm>
-            <a:off x="3471863" y="2988734"/>
-            <a:ext cx="2915543" cy="1464732"/>
+            <a:off x="1822728" y="2612029"/>
+            <a:ext cx="1530660" cy="1280115"/>
           </a:xfrm>
         </p:spPr>
         <p:txBody>
@@ -1500,39 +2113,39 @@
           <a:lstStyle>
             <a:lvl1pPr marL="0" indent="0">
               <a:buNone/>
-              <a:defRPr sz="1800" b="1"/>
+              <a:defRPr sz="945" b="1"/>
             </a:lvl1pPr>
-            <a:lvl2pPr marL="342900" indent="0">
-              <a:buNone/>
-              <a:defRPr sz="1500" b="1"/>
+            <a:lvl2pPr marL="180045" indent="0">
+              <a:buNone/>
+              <a:defRPr sz="788" b="1"/>
             </a:lvl2pPr>
-            <a:lvl3pPr marL="685800" indent="0">
-              <a:buNone/>
-              <a:defRPr sz="1350" b="1"/>
+            <a:lvl3pPr marL="360091" indent="0">
+              <a:buNone/>
+              <a:defRPr sz="709" b="1"/>
             </a:lvl3pPr>
-            <a:lvl4pPr marL="1028700" indent="0">
-              <a:buNone/>
-              <a:defRPr sz="1200" b="1"/>
+            <a:lvl4pPr marL="540136" indent="0">
+              <a:buNone/>
+              <a:defRPr sz="630" b="1"/>
             </a:lvl4pPr>
-            <a:lvl5pPr marL="1371600" indent="0">
-              <a:buNone/>
-              <a:defRPr sz="1200" b="1"/>
+            <a:lvl5pPr marL="720181" indent="0">
+              <a:buNone/>
+              <a:defRPr sz="630" b="1"/>
             </a:lvl5pPr>
-            <a:lvl6pPr marL="1714500" indent="0">
-              <a:buNone/>
-              <a:defRPr sz="1200" b="1"/>
+            <a:lvl6pPr marL="900227" indent="0">
+              <a:buNone/>
+              <a:defRPr sz="630" b="1"/>
             </a:lvl6pPr>
-            <a:lvl7pPr marL="2057400" indent="0">
-              <a:buNone/>
-              <a:defRPr sz="1200" b="1"/>
+            <a:lvl7pPr marL="1080272" indent="0">
+              <a:buNone/>
+              <a:defRPr sz="630" b="1"/>
             </a:lvl7pPr>
-            <a:lvl8pPr marL="2400300" indent="0">
-              <a:buNone/>
-              <a:defRPr sz="1200" b="1"/>
+            <a:lvl8pPr marL="1260318" indent="0">
+              <a:buNone/>
+              <a:defRPr sz="630" b="1"/>
             </a:lvl8pPr>
-            <a:lvl9pPr marL="2743200" indent="0">
-              <a:buNone/>
-              <a:defRPr sz="1200" b="1"/>
+            <a:lvl9pPr marL="1440363" indent="0">
+              <a:buNone/>
+              <a:defRPr sz="630" b="1"/>
             </a:lvl9pPr>
           </a:lstStyle>
           <a:p>
@@ -1556,8 +2169,8 @@
         </p:nvSpPr>
         <p:spPr>
           <a:xfrm>
-            <a:off x="3471863" y="4453467"/>
-            <a:ext cx="2915543" cy="6550379"/>
+            <a:off x="1822728" y="3892144"/>
+            <a:ext cx="1530660" cy="5724758"/>
           </a:xfrm>
         </p:spPr>
         <p:txBody>
@@ -1618,7 +2231,7 @@
           <a:p>
             <a:fld id="{5802A5F5-DD2A-4576-86B6-34DB5722830F}" type="datetimeFigureOut">
               <a:rPr lang="ko-KR" altLang="en-US" smtClean="0"/>
-              <a:t>2025-11-14</a:t>
+              <a:t>2026-02-26</a:t>
             </a:fld>
             <a:endParaRPr lang="ko-KR" altLang="en-US"/>
           </a:p>
@@ -1669,7 +2282,7 @@
     </p:spTree>
     <p:extLst>
       <p:ext uri="{BB962C8B-B14F-4D97-AF65-F5344CB8AC3E}">
-        <p14:creationId xmlns:p14="http://schemas.microsoft.com/office/powerpoint/2010/main" val="2631346068"/>
+        <p14:creationId xmlns:p14="http://schemas.microsoft.com/office/powerpoint/2010/main" val="1302785999"/>
       </p:ext>
     </p:extLst>
   </p:cSld>
@@ -1736,7 +2349,7 @@
           <a:p>
             <a:fld id="{5802A5F5-DD2A-4576-86B6-34DB5722830F}" type="datetimeFigureOut">
               <a:rPr lang="ko-KR" altLang="en-US" smtClean="0"/>
-              <a:t>2025-11-14</a:t>
+              <a:t>2026-02-26</a:t>
             </a:fld>
             <a:endParaRPr lang="ko-KR" altLang="en-US"/>
           </a:p>
@@ -1787,7 +2400,7 @@
     </p:spTree>
     <p:extLst>
       <p:ext uri="{BB962C8B-B14F-4D97-AF65-F5344CB8AC3E}">
-        <p14:creationId xmlns:p14="http://schemas.microsoft.com/office/powerpoint/2010/main" val="1528301833"/>
+        <p14:creationId xmlns:p14="http://schemas.microsoft.com/office/powerpoint/2010/main" val="2305087029"/>
       </p:ext>
     </p:extLst>
   </p:cSld>
@@ -1831,7 +2444,7 @@
           <a:p>
             <a:fld id="{5802A5F5-DD2A-4576-86B6-34DB5722830F}" type="datetimeFigureOut">
               <a:rPr lang="ko-KR" altLang="en-US" smtClean="0"/>
-              <a:t>2025-11-14</a:t>
+              <a:t>2026-02-26</a:t>
             </a:fld>
             <a:endParaRPr lang="ko-KR" altLang="en-US"/>
           </a:p>
@@ -1882,7 +2495,7 @@
     </p:spTree>
     <p:extLst>
       <p:ext uri="{BB962C8B-B14F-4D97-AF65-F5344CB8AC3E}">
-        <p14:creationId xmlns:p14="http://schemas.microsoft.com/office/powerpoint/2010/main" val="807684508"/>
+        <p14:creationId xmlns:p14="http://schemas.microsoft.com/office/powerpoint/2010/main" val="2971703000"/>
       </p:ext>
     </p:extLst>
   </p:cSld>
@@ -1921,15 +2534,15 @@
         </p:nvSpPr>
         <p:spPr>
           <a:xfrm>
-            <a:off x="472381" y="812800"/>
-            <a:ext cx="2211884" cy="2844800"/>
+            <a:off x="248000" y="710353"/>
+            <a:ext cx="1161239" cy="2486237"/>
           </a:xfrm>
         </p:spPr>
         <p:txBody>
           <a:bodyPr anchor="b"/>
           <a:lstStyle>
             <a:lvl1pPr>
-              <a:defRPr sz="2400"/>
+              <a:defRPr sz="1260"/>
             </a:lvl1pPr>
           </a:lstStyle>
           <a:p>
@@ -1953,39 +2566,39 @@
         </p:nvSpPr>
         <p:spPr>
           <a:xfrm>
-            <a:off x="2915543" y="1755425"/>
-            <a:ext cx="3471863" cy="8664222"/>
+            <a:off x="1530660" y="1534168"/>
+            <a:ext cx="1822728" cy="7572169"/>
           </a:xfrm>
         </p:spPr>
         <p:txBody>
           <a:bodyPr/>
           <a:lstStyle>
             <a:lvl1pPr>
-              <a:defRPr sz="2400"/>
+              <a:defRPr sz="1260"/>
             </a:lvl1pPr>
             <a:lvl2pPr>
-              <a:defRPr sz="2100"/>
+              <a:defRPr sz="1103"/>
             </a:lvl2pPr>
             <a:lvl3pPr>
-              <a:defRPr sz="1800"/>
+              <a:defRPr sz="945"/>
             </a:lvl3pPr>
             <a:lvl4pPr>
-              <a:defRPr sz="1500"/>
+              <a:defRPr sz="788"/>
             </a:lvl4pPr>
             <a:lvl5pPr>
-              <a:defRPr sz="1500"/>
+              <a:defRPr sz="788"/>
             </a:lvl5pPr>
             <a:lvl6pPr>
-              <a:defRPr sz="1500"/>
+              <a:defRPr sz="788"/>
             </a:lvl6pPr>
             <a:lvl7pPr>
-              <a:defRPr sz="1500"/>
+              <a:defRPr sz="788"/>
             </a:lvl7pPr>
             <a:lvl8pPr>
-              <a:defRPr sz="1500"/>
+              <a:defRPr sz="788"/>
             </a:lvl8pPr>
             <a:lvl9pPr>
-              <a:defRPr sz="1500"/>
+              <a:defRPr sz="788"/>
             </a:lvl9pPr>
           </a:lstStyle>
           <a:p>
@@ -2038,8 +2651,8 @@
         </p:nvSpPr>
         <p:spPr>
           <a:xfrm>
-            <a:off x="472381" y="3657600"/>
-            <a:ext cx="2211884" cy="6776156"/>
+            <a:off x="248000" y="3196590"/>
+            <a:ext cx="1161239" cy="5922078"/>
           </a:xfrm>
         </p:spPr>
         <p:txBody>
@@ -2047,39 +2660,39 @@
           <a:lstStyle>
             <a:lvl1pPr marL="0" indent="0">
               <a:buNone/>
-              <a:defRPr sz="1200"/>
+              <a:defRPr sz="630"/>
             </a:lvl1pPr>
-            <a:lvl2pPr marL="342900" indent="0">
-              <a:buNone/>
-              <a:defRPr sz="1050"/>
+            <a:lvl2pPr marL="180045" indent="0">
+              <a:buNone/>
+              <a:defRPr sz="551"/>
             </a:lvl2pPr>
-            <a:lvl3pPr marL="685800" indent="0">
-              <a:buNone/>
-              <a:defRPr sz="900"/>
+            <a:lvl3pPr marL="360091" indent="0">
+              <a:buNone/>
+              <a:defRPr sz="473"/>
             </a:lvl3pPr>
-            <a:lvl4pPr marL="1028700" indent="0">
-              <a:buNone/>
-              <a:defRPr sz="750"/>
+            <a:lvl4pPr marL="540136" indent="0">
+              <a:buNone/>
+              <a:defRPr sz="394"/>
             </a:lvl4pPr>
-            <a:lvl5pPr marL="1371600" indent="0">
-              <a:buNone/>
-              <a:defRPr sz="750"/>
+            <a:lvl5pPr marL="720181" indent="0">
+              <a:buNone/>
+              <a:defRPr sz="394"/>
             </a:lvl5pPr>
-            <a:lvl6pPr marL="1714500" indent="0">
-              <a:buNone/>
-              <a:defRPr sz="750"/>
+            <a:lvl6pPr marL="900227" indent="0">
+              <a:buNone/>
+              <a:defRPr sz="394"/>
             </a:lvl6pPr>
-            <a:lvl7pPr marL="2057400" indent="0">
-              <a:buNone/>
-              <a:defRPr sz="750"/>
+            <a:lvl7pPr marL="1080272" indent="0">
+              <a:buNone/>
+              <a:defRPr sz="394"/>
             </a:lvl7pPr>
-            <a:lvl8pPr marL="2400300" indent="0">
-              <a:buNone/>
-              <a:defRPr sz="750"/>
+            <a:lvl8pPr marL="1260318" indent="0">
+              <a:buNone/>
+              <a:defRPr sz="394"/>
             </a:lvl8pPr>
-            <a:lvl9pPr marL="2743200" indent="0">
-              <a:buNone/>
-              <a:defRPr sz="750"/>
+            <a:lvl9pPr marL="1440363" indent="0">
+              <a:buNone/>
+              <a:defRPr sz="394"/>
             </a:lvl9pPr>
           </a:lstStyle>
           <a:p>
@@ -2108,7 +2721,7 @@
           <a:p>
             <a:fld id="{5802A5F5-DD2A-4576-86B6-34DB5722830F}" type="datetimeFigureOut">
               <a:rPr lang="ko-KR" altLang="en-US" smtClean="0"/>
-              <a:t>2025-11-14</a:t>
+              <a:t>2026-02-26</a:t>
             </a:fld>
             <a:endParaRPr lang="ko-KR" altLang="en-US"/>
           </a:p>
@@ -2159,7 +2772,7 @@
     </p:spTree>
     <p:extLst>
       <p:ext uri="{BB962C8B-B14F-4D97-AF65-F5344CB8AC3E}">
-        <p14:creationId xmlns:p14="http://schemas.microsoft.com/office/powerpoint/2010/main" val="267031827"/>
+        <p14:creationId xmlns:p14="http://schemas.microsoft.com/office/powerpoint/2010/main" val="1264775203"/>
       </p:ext>
     </p:extLst>
   </p:cSld>
@@ -2198,15 +2811,15 @@
         </p:nvSpPr>
         <p:spPr>
           <a:xfrm>
-            <a:off x="472381" y="812800"/>
-            <a:ext cx="2211884" cy="2844800"/>
+            <a:off x="248000" y="710353"/>
+            <a:ext cx="1161239" cy="2486237"/>
           </a:xfrm>
         </p:spPr>
         <p:txBody>
           <a:bodyPr anchor="b"/>
           <a:lstStyle>
             <a:lvl1pPr>
-              <a:defRPr sz="2400"/>
+              <a:defRPr sz="1260"/>
             </a:lvl1pPr>
           </a:lstStyle>
           <a:p>
@@ -2230,8 +2843,8 @@
         </p:nvSpPr>
         <p:spPr>
           <a:xfrm>
-            <a:off x="2915543" y="1755425"/>
-            <a:ext cx="3471863" cy="8664222"/>
+            <a:off x="1530660" y="1534168"/>
+            <a:ext cx="1822728" cy="7572169"/>
           </a:xfrm>
         </p:spPr>
         <p:txBody>
@@ -2239,39 +2852,39 @@
           <a:lstStyle>
             <a:lvl1pPr marL="0" indent="0">
               <a:buNone/>
-              <a:defRPr sz="2400"/>
+              <a:defRPr sz="1260"/>
             </a:lvl1pPr>
-            <a:lvl2pPr marL="342900" indent="0">
-              <a:buNone/>
-              <a:defRPr sz="2100"/>
+            <a:lvl2pPr marL="180045" indent="0">
+              <a:buNone/>
+              <a:defRPr sz="1103"/>
             </a:lvl2pPr>
-            <a:lvl3pPr marL="685800" indent="0">
-              <a:buNone/>
-              <a:defRPr sz="1800"/>
+            <a:lvl3pPr marL="360091" indent="0">
+              <a:buNone/>
+              <a:defRPr sz="945"/>
             </a:lvl3pPr>
-            <a:lvl4pPr marL="1028700" indent="0">
-              <a:buNone/>
-              <a:defRPr sz="1500"/>
+            <a:lvl4pPr marL="540136" indent="0">
+              <a:buNone/>
+              <a:defRPr sz="788"/>
             </a:lvl4pPr>
-            <a:lvl5pPr marL="1371600" indent="0">
-              <a:buNone/>
-              <a:defRPr sz="1500"/>
+            <a:lvl5pPr marL="720181" indent="0">
+              <a:buNone/>
+              <a:defRPr sz="788"/>
             </a:lvl5pPr>
-            <a:lvl6pPr marL="1714500" indent="0">
-              <a:buNone/>
-              <a:defRPr sz="1500"/>
+            <a:lvl6pPr marL="900227" indent="0">
+              <a:buNone/>
+              <a:defRPr sz="788"/>
             </a:lvl6pPr>
-            <a:lvl7pPr marL="2057400" indent="0">
-              <a:buNone/>
-              <a:defRPr sz="1500"/>
+            <a:lvl7pPr marL="1080272" indent="0">
+              <a:buNone/>
+              <a:defRPr sz="788"/>
             </a:lvl7pPr>
-            <a:lvl8pPr marL="2400300" indent="0">
-              <a:buNone/>
-              <a:defRPr sz="1500"/>
+            <a:lvl8pPr marL="1260318" indent="0">
+              <a:buNone/>
+              <a:defRPr sz="788"/>
             </a:lvl8pPr>
-            <a:lvl9pPr marL="2743200" indent="0">
-              <a:buNone/>
-              <a:defRPr sz="1500"/>
+            <a:lvl9pPr marL="1440363" indent="0">
+              <a:buNone/>
+              <a:defRPr sz="788"/>
             </a:lvl9pPr>
           </a:lstStyle>
           <a:p>
@@ -2279,7 +2892,7 @@
               <a:rPr lang="ko-KR" altLang="en-US"/>
               <a:t>그림을 추가하려면 아이콘을 클릭하십시오</a:t>
             </a:r>
-            <a:endParaRPr lang="en-US" dirty="0"/>
+            <a:endParaRPr lang="en-US"/>
           </a:p>
         </p:txBody>
       </p:sp>
@@ -2295,8 +2908,8 @@
         </p:nvSpPr>
         <p:spPr>
           <a:xfrm>
-            <a:off x="472381" y="3657600"/>
-            <a:ext cx="2211884" cy="6776156"/>
+            <a:off x="248000" y="3196590"/>
+            <a:ext cx="1161239" cy="5922078"/>
           </a:xfrm>
         </p:spPr>
         <p:txBody>
@@ -2304,39 +2917,39 @@
           <a:lstStyle>
             <a:lvl1pPr marL="0" indent="0">
               <a:buNone/>
-              <a:defRPr sz="1200"/>
+              <a:defRPr sz="630"/>
             </a:lvl1pPr>
-            <a:lvl2pPr marL="342900" indent="0">
-              <a:buNone/>
-              <a:defRPr sz="1050"/>
+            <a:lvl2pPr marL="180045" indent="0">
+              <a:buNone/>
+              <a:defRPr sz="551"/>
             </a:lvl2pPr>
-            <a:lvl3pPr marL="685800" indent="0">
-              <a:buNone/>
-              <a:defRPr sz="900"/>
+            <a:lvl3pPr marL="360091" indent="0">
+              <a:buNone/>
+              <a:defRPr sz="473"/>
             </a:lvl3pPr>
-            <a:lvl4pPr marL="1028700" indent="0">
-              <a:buNone/>
-              <a:defRPr sz="750"/>
+            <a:lvl4pPr marL="540136" indent="0">
+              <a:buNone/>
+              <a:defRPr sz="394"/>
             </a:lvl4pPr>
-            <a:lvl5pPr marL="1371600" indent="0">
-              <a:buNone/>
-              <a:defRPr sz="750"/>
+            <a:lvl5pPr marL="720181" indent="0">
+              <a:buNone/>
+              <a:defRPr sz="394"/>
             </a:lvl5pPr>
-            <a:lvl6pPr marL="1714500" indent="0">
-              <a:buNone/>
-              <a:defRPr sz="750"/>
+            <a:lvl6pPr marL="900227" indent="0">
+              <a:buNone/>
+              <a:defRPr sz="394"/>
             </a:lvl6pPr>
-            <a:lvl7pPr marL="2057400" indent="0">
-              <a:buNone/>
-              <a:defRPr sz="750"/>
+            <a:lvl7pPr marL="1080272" indent="0">
+              <a:buNone/>
+              <a:defRPr sz="394"/>
             </a:lvl7pPr>
-            <a:lvl8pPr marL="2400300" indent="0">
-              <a:buNone/>
-              <a:defRPr sz="750"/>
+            <a:lvl8pPr marL="1260318" indent="0">
+              <a:buNone/>
+              <a:defRPr sz="394"/>
             </a:lvl8pPr>
-            <a:lvl9pPr marL="2743200" indent="0">
-              <a:buNone/>
-              <a:defRPr sz="750"/>
+            <a:lvl9pPr marL="1440363" indent="0">
+              <a:buNone/>
+              <a:defRPr sz="394"/>
             </a:lvl9pPr>
           </a:lstStyle>
           <a:p>
@@ -2365,7 +2978,7 @@
           <a:p>
             <a:fld id="{5802A5F5-DD2A-4576-86B6-34DB5722830F}" type="datetimeFigureOut">
               <a:rPr lang="ko-KR" altLang="en-US" smtClean="0"/>
-              <a:t>2025-11-14</a:t>
+              <a:t>2026-02-26</a:t>
             </a:fld>
             <a:endParaRPr lang="ko-KR" altLang="en-US"/>
           </a:p>
@@ -2416,7 +3029,7 @@
     </p:spTree>
     <p:extLst>
       <p:ext uri="{BB962C8B-B14F-4D97-AF65-F5344CB8AC3E}">
-        <p14:creationId xmlns:p14="http://schemas.microsoft.com/office/powerpoint/2010/main" val="2470020471"/>
+        <p14:creationId xmlns:p14="http://schemas.microsoft.com/office/powerpoint/2010/main" val="2508686917"/>
       </p:ext>
     </p:extLst>
   </p:cSld>
@@ -2460,8 +3073,8 @@
         </p:nvSpPr>
         <p:spPr>
           <a:xfrm>
-            <a:off x="471488" y="649114"/>
-            <a:ext cx="5915025" cy="2356556"/>
+            <a:off x="247531" y="567298"/>
+            <a:ext cx="3105388" cy="2059532"/>
           </a:xfrm>
           <a:prstGeom prst="rect">
             <a:avLst/>
@@ -2493,8 +3106,8 @@
         </p:nvSpPr>
         <p:spPr>
           <a:xfrm>
-            <a:off x="471488" y="3245556"/>
-            <a:ext cx="5915025" cy="7735712"/>
+            <a:off x="247531" y="2836480"/>
+            <a:ext cx="3105388" cy="6760690"/>
           </a:xfrm>
           <a:prstGeom prst="rect">
             <a:avLst/>
@@ -2555,8 +3168,8 @@
         </p:nvSpPr>
         <p:spPr>
           <a:xfrm>
-            <a:off x="471488" y="11300181"/>
-            <a:ext cx="1543050" cy="649111"/>
+            <a:off x="247531" y="9875887"/>
+            <a:ext cx="810101" cy="567296"/>
           </a:xfrm>
           <a:prstGeom prst="rect">
             <a:avLst/>
@@ -2566,7 +3179,7 @@
           <a:bodyPr vert="horz" lIns="91440" tIns="45720" rIns="91440" bIns="45720" rtlCol="0" anchor="ctr"/>
           <a:lstStyle>
             <a:lvl1pPr algn="l">
-              <a:defRPr sz="900">
+              <a:defRPr sz="473">
                 <a:solidFill>
                   <a:schemeClr val="tx1">
                     <a:tint val="75000"/>
@@ -2578,7 +3191,7 @@
           <a:p>
             <a:fld id="{5802A5F5-DD2A-4576-86B6-34DB5722830F}" type="datetimeFigureOut">
               <a:rPr lang="ko-KR" altLang="en-US" smtClean="0"/>
-              <a:t>2025-11-14</a:t>
+              <a:t>2026-02-26</a:t>
             </a:fld>
             <a:endParaRPr lang="ko-KR" altLang="en-US"/>
           </a:p>
@@ -2596,8 +3209,8 @@
         </p:nvSpPr>
         <p:spPr>
           <a:xfrm>
-            <a:off x="2271713" y="11300181"/>
-            <a:ext cx="2314575" cy="649111"/>
+            <a:off x="1192649" y="9875887"/>
+            <a:ext cx="1215152" cy="567296"/>
           </a:xfrm>
           <a:prstGeom prst="rect">
             <a:avLst/>
@@ -2607,7 +3220,7 @@
           <a:bodyPr vert="horz" lIns="91440" tIns="45720" rIns="91440" bIns="45720" rtlCol="0" anchor="ctr"/>
           <a:lstStyle>
             <a:lvl1pPr algn="ctr">
-              <a:defRPr sz="900">
+              <a:defRPr sz="473">
                 <a:solidFill>
                   <a:schemeClr val="tx1">
                     <a:tint val="75000"/>
@@ -2633,8 +3246,8 @@
         </p:nvSpPr>
         <p:spPr>
           <a:xfrm>
-            <a:off x="4843463" y="11300181"/>
-            <a:ext cx="1543050" cy="649111"/>
+            <a:off x="2542818" y="9875887"/>
+            <a:ext cx="810101" cy="567296"/>
           </a:xfrm>
           <a:prstGeom prst="rect">
             <a:avLst/>
@@ -2644,7 +3257,7 @@
           <a:bodyPr vert="horz" lIns="91440" tIns="45720" rIns="91440" bIns="45720" rtlCol="0" anchor="ctr"/>
           <a:lstStyle>
             <a:lvl1pPr algn="r">
-              <a:defRPr sz="900">
+              <a:defRPr sz="473">
                 <a:solidFill>
                   <a:schemeClr val="tx1">
                     <a:tint val="75000"/>
@@ -2665,27 +3278,27 @@
     </p:spTree>
     <p:extLst>
       <p:ext uri="{BB962C8B-B14F-4D97-AF65-F5344CB8AC3E}">
-        <p14:creationId xmlns:p14="http://schemas.microsoft.com/office/powerpoint/2010/main" val="2289492503"/>
+        <p14:creationId xmlns:p14="http://schemas.microsoft.com/office/powerpoint/2010/main" val="4217757297"/>
       </p:ext>
     </p:extLst>
   </p:cSld>
   <p:clrMap bg1="lt1" tx1="dk1" bg2="lt2" tx2="dk2" accent1="accent1" accent2="accent2" accent3="accent3" accent4="accent4" accent5="accent5" accent6="accent6" hlink="hlink" folHlink="folHlink"/>
   <p:sldLayoutIdLst>
-    <p:sldLayoutId id="2147483661" r:id="rId1"/>
-    <p:sldLayoutId id="2147483662" r:id="rId2"/>
-    <p:sldLayoutId id="2147483663" r:id="rId3"/>
-    <p:sldLayoutId id="2147483664" r:id="rId4"/>
-    <p:sldLayoutId id="2147483665" r:id="rId5"/>
-    <p:sldLayoutId id="2147483666" r:id="rId6"/>
-    <p:sldLayoutId id="2147483667" r:id="rId7"/>
-    <p:sldLayoutId id="2147483668" r:id="rId8"/>
-    <p:sldLayoutId id="2147483669" r:id="rId9"/>
-    <p:sldLayoutId id="2147483670" r:id="rId10"/>
-    <p:sldLayoutId id="2147483671" r:id="rId11"/>
+    <p:sldLayoutId id="2147483673" r:id="rId1"/>
+    <p:sldLayoutId id="2147483674" r:id="rId2"/>
+    <p:sldLayoutId id="2147483675" r:id="rId3"/>
+    <p:sldLayoutId id="2147483676" r:id="rId4"/>
+    <p:sldLayoutId id="2147483677" r:id="rId5"/>
+    <p:sldLayoutId id="2147483678" r:id="rId6"/>
+    <p:sldLayoutId id="2147483679" r:id="rId7"/>
+    <p:sldLayoutId id="2147483680" r:id="rId8"/>
+    <p:sldLayoutId id="2147483681" r:id="rId9"/>
+    <p:sldLayoutId id="2147483682" r:id="rId10"/>
+    <p:sldLayoutId id="2147483683" r:id="rId11"/>
   </p:sldLayoutIdLst>
   <p:txStyles>
     <p:titleStyle>
-      <a:lvl1pPr algn="l" defTabSz="685800" rtl="0" eaLnBrk="1" latinLnBrk="1" hangingPunct="1">
+      <a:lvl1pPr algn="l" defTabSz="360091" rtl="0" eaLnBrk="1" latinLnBrk="1" hangingPunct="1">
         <a:lnSpc>
           <a:spcPct val="90000"/>
         </a:lnSpc>
@@ -2693,7 +3306,7 @@
           <a:spcPct val="0"/>
         </a:spcBef>
         <a:buNone/>
-        <a:defRPr sz="3300" kern="1200">
+        <a:defRPr sz="1733" kern="1200">
           <a:solidFill>
             <a:schemeClr val="tx1"/>
           </a:solidFill>
@@ -2704,16 +3317,16 @@
       </a:lvl1pPr>
     </p:titleStyle>
     <p:bodyStyle>
-      <a:lvl1pPr marL="171450" indent="-171450" algn="l" defTabSz="685800" rtl="0" eaLnBrk="1" latinLnBrk="1" hangingPunct="1">
+      <a:lvl1pPr marL="90023" indent="-90023" algn="l" defTabSz="360091" rtl="0" eaLnBrk="1" latinLnBrk="1" hangingPunct="1">
         <a:lnSpc>
           <a:spcPct val="90000"/>
         </a:lnSpc>
         <a:spcBef>
-          <a:spcPts val="750"/>
+          <a:spcPts val="394"/>
         </a:spcBef>
         <a:buFont typeface="Arial" panose="020B0604020202020204" pitchFamily="34" charset="0"/>
         <a:buChar char="•"/>
-        <a:defRPr sz="2100" kern="1200">
+        <a:defRPr sz="1103" kern="1200">
           <a:solidFill>
             <a:schemeClr val="tx1"/>
           </a:solidFill>
@@ -2722,16 +3335,16 @@
           <a:cs typeface="+mn-cs"/>
         </a:defRPr>
       </a:lvl1pPr>
-      <a:lvl2pPr marL="514350" indent="-171450" algn="l" defTabSz="685800" rtl="0" eaLnBrk="1" latinLnBrk="1" hangingPunct="1">
+      <a:lvl2pPr marL="270068" indent="-90023" algn="l" defTabSz="360091" rtl="0" eaLnBrk="1" latinLnBrk="1" hangingPunct="1">
         <a:lnSpc>
           <a:spcPct val="90000"/>
         </a:lnSpc>
         <a:spcBef>
-          <a:spcPts val="375"/>
+          <a:spcPts val="197"/>
         </a:spcBef>
         <a:buFont typeface="Arial" panose="020B0604020202020204" pitchFamily="34" charset="0"/>
         <a:buChar char="•"/>
-        <a:defRPr sz="1800" kern="1200">
+        <a:defRPr sz="945" kern="1200">
           <a:solidFill>
             <a:schemeClr val="tx1"/>
           </a:solidFill>
@@ -2740,16 +3353,16 @@
           <a:cs typeface="+mn-cs"/>
         </a:defRPr>
       </a:lvl2pPr>
-      <a:lvl3pPr marL="857250" indent="-171450" algn="l" defTabSz="685800" rtl="0" eaLnBrk="1" latinLnBrk="1" hangingPunct="1">
+      <a:lvl3pPr marL="450113" indent="-90023" algn="l" defTabSz="360091" rtl="0" eaLnBrk="1" latinLnBrk="1" hangingPunct="1">
         <a:lnSpc>
           <a:spcPct val="90000"/>
         </a:lnSpc>
         <a:spcBef>
-          <a:spcPts val="375"/>
+          <a:spcPts val="197"/>
         </a:spcBef>
         <a:buFont typeface="Arial" panose="020B0604020202020204" pitchFamily="34" charset="0"/>
         <a:buChar char="•"/>
-        <a:defRPr sz="1500" kern="1200">
+        <a:defRPr sz="788" kern="1200">
           <a:solidFill>
             <a:schemeClr val="tx1"/>
           </a:solidFill>
@@ -2758,16 +3371,16 @@
           <a:cs typeface="+mn-cs"/>
         </a:defRPr>
       </a:lvl3pPr>
-      <a:lvl4pPr marL="1200150" indent="-171450" algn="l" defTabSz="685800" rtl="0" eaLnBrk="1" latinLnBrk="1" hangingPunct="1">
+      <a:lvl4pPr marL="630159" indent="-90023" algn="l" defTabSz="360091" rtl="0" eaLnBrk="1" latinLnBrk="1" hangingPunct="1">
         <a:lnSpc>
           <a:spcPct val="90000"/>
         </a:lnSpc>
         <a:spcBef>
-          <a:spcPts val="375"/>
+          <a:spcPts val="197"/>
         </a:spcBef>
         <a:buFont typeface="Arial" panose="020B0604020202020204" pitchFamily="34" charset="0"/>
         <a:buChar char="•"/>
-        <a:defRPr sz="1350" kern="1200">
+        <a:defRPr sz="709" kern="1200">
           <a:solidFill>
             <a:schemeClr val="tx1"/>
           </a:solidFill>
@@ -2776,16 +3389,16 @@
           <a:cs typeface="+mn-cs"/>
         </a:defRPr>
       </a:lvl4pPr>
-      <a:lvl5pPr marL="1543050" indent="-171450" algn="l" defTabSz="685800" rtl="0" eaLnBrk="1" latinLnBrk="1" hangingPunct="1">
+      <a:lvl5pPr marL="810204" indent="-90023" algn="l" defTabSz="360091" rtl="0" eaLnBrk="1" latinLnBrk="1" hangingPunct="1">
         <a:lnSpc>
           <a:spcPct val="90000"/>
         </a:lnSpc>
         <a:spcBef>
-          <a:spcPts val="375"/>
+          <a:spcPts val="197"/>
         </a:spcBef>
         <a:buFont typeface="Arial" panose="020B0604020202020204" pitchFamily="34" charset="0"/>
         <a:buChar char="•"/>
-        <a:defRPr sz="1350" kern="1200">
+        <a:defRPr sz="709" kern="1200">
           <a:solidFill>
             <a:schemeClr val="tx1"/>
           </a:solidFill>
@@ -2794,16 +3407,16 @@
           <a:cs typeface="+mn-cs"/>
         </a:defRPr>
       </a:lvl5pPr>
-      <a:lvl6pPr marL="1885950" indent="-171450" algn="l" defTabSz="685800" rtl="0" eaLnBrk="1" latinLnBrk="1" hangingPunct="1">
+      <a:lvl6pPr marL="990249" indent="-90023" algn="l" defTabSz="360091" rtl="0" eaLnBrk="1" latinLnBrk="1" hangingPunct="1">
         <a:lnSpc>
           <a:spcPct val="90000"/>
         </a:lnSpc>
         <a:spcBef>
-          <a:spcPts val="375"/>
+          <a:spcPts val="197"/>
         </a:spcBef>
         <a:buFont typeface="Arial" panose="020B0604020202020204" pitchFamily="34" charset="0"/>
         <a:buChar char="•"/>
-        <a:defRPr sz="1350" kern="1200">
+        <a:defRPr sz="709" kern="1200">
           <a:solidFill>
             <a:schemeClr val="tx1"/>
           </a:solidFill>
@@ -2812,16 +3425,16 @@
           <a:cs typeface="+mn-cs"/>
         </a:defRPr>
       </a:lvl6pPr>
-      <a:lvl7pPr marL="2228850" indent="-171450" algn="l" defTabSz="685800" rtl="0" eaLnBrk="1" latinLnBrk="1" hangingPunct="1">
+      <a:lvl7pPr marL="1170295" indent="-90023" algn="l" defTabSz="360091" rtl="0" eaLnBrk="1" latinLnBrk="1" hangingPunct="1">
         <a:lnSpc>
           <a:spcPct val="90000"/>
         </a:lnSpc>
         <a:spcBef>
-          <a:spcPts val="375"/>
+          <a:spcPts val="197"/>
         </a:spcBef>
         <a:buFont typeface="Arial" panose="020B0604020202020204" pitchFamily="34" charset="0"/>
         <a:buChar char="•"/>
-        <a:defRPr sz="1350" kern="1200">
+        <a:defRPr sz="709" kern="1200">
           <a:solidFill>
             <a:schemeClr val="tx1"/>
           </a:solidFill>
@@ -2830,16 +3443,16 @@
           <a:cs typeface="+mn-cs"/>
         </a:defRPr>
       </a:lvl7pPr>
-      <a:lvl8pPr marL="2571750" indent="-171450" algn="l" defTabSz="685800" rtl="0" eaLnBrk="1" latinLnBrk="1" hangingPunct="1">
+      <a:lvl8pPr marL="1350340" indent="-90023" algn="l" defTabSz="360091" rtl="0" eaLnBrk="1" latinLnBrk="1" hangingPunct="1">
         <a:lnSpc>
           <a:spcPct val="90000"/>
         </a:lnSpc>
         <a:spcBef>
-          <a:spcPts val="375"/>
+          <a:spcPts val="197"/>
         </a:spcBef>
         <a:buFont typeface="Arial" panose="020B0604020202020204" pitchFamily="34" charset="0"/>
         <a:buChar char="•"/>
-        <a:defRPr sz="1350" kern="1200">
+        <a:defRPr sz="709" kern="1200">
           <a:solidFill>
             <a:schemeClr val="tx1"/>
           </a:solidFill>
@@ -2848,16 +3461,16 @@
           <a:cs typeface="+mn-cs"/>
         </a:defRPr>
       </a:lvl8pPr>
-      <a:lvl9pPr marL="2914650" indent="-171450" algn="l" defTabSz="685800" rtl="0" eaLnBrk="1" latinLnBrk="1" hangingPunct="1">
+      <a:lvl9pPr marL="1530386" indent="-90023" algn="l" defTabSz="360091" rtl="0" eaLnBrk="1" latinLnBrk="1" hangingPunct="1">
         <a:lnSpc>
           <a:spcPct val="90000"/>
         </a:lnSpc>
         <a:spcBef>
-          <a:spcPts val="375"/>
+          <a:spcPts val="197"/>
         </a:spcBef>
         <a:buFont typeface="Arial" panose="020B0604020202020204" pitchFamily="34" charset="0"/>
         <a:buChar char="•"/>
-        <a:defRPr sz="1350" kern="1200">
+        <a:defRPr sz="709" kern="1200">
           <a:solidFill>
             <a:schemeClr val="tx1"/>
           </a:solidFill>
@@ -2871,8 +3484,8 @@
       <a:defPPr>
         <a:defRPr lang="en-US"/>
       </a:defPPr>
-      <a:lvl1pPr marL="0" algn="l" defTabSz="685800" rtl="0" eaLnBrk="1" latinLnBrk="1" hangingPunct="1">
-        <a:defRPr sz="1350" kern="1200">
+      <a:lvl1pPr marL="0" algn="l" defTabSz="360091" rtl="0" eaLnBrk="1" latinLnBrk="1" hangingPunct="1">
+        <a:defRPr sz="709" kern="1200">
           <a:solidFill>
             <a:schemeClr val="tx1"/>
           </a:solidFill>
@@ -2881,8 +3494,8 @@
           <a:cs typeface="+mn-cs"/>
         </a:defRPr>
       </a:lvl1pPr>
-      <a:lvl2pPr marL="342900" algn="l" defTabSz="685800" rtl="0" eaLnBrk="1" latinLnBrk="1" hangingPunct="1">
-        <a:defRPr sz="1350" kern="1200">
+      <a:lvl2pPr marL="180045" algn="l" defTabSz="360091" rtl="0" eaLnBrk="1" latinLnBrk="1" hangingPunct="1">
+        <a:defRPr sz="709" kern="1200">
           <a:solidFill>
             <a:schemeClr val="tx1"/>
           </a:solidFill>
@@ -2891,8 +3504,8 @@
           <a:cs typeface="+mn-cs"/>
         </a:defRPr>
       </a:lvl2pPr>
-      <a:lvl3pPr marL="685800" algn="l" defTabSz="685800" rtl="0" eaLnBrk="1" latinLnBrk="1" hangingPunct="1">
-        <a:defRPr sz="1350" kern="1200">
+      <a:lvl3pPr marL="360091" algn="l" defTabSz="360091" rtl="0" eaLnBrk="1" latinLnBrk="1" hangingPunct="1">
+        <a:defRPr sz="709" kern="1200">
           <a:solidFill>
             <a:schemeClr val="tx1"/>
           </a:solidFill>
@@ -2901,8 +3514,8 @@
           <a:cs typeface="+mn-cs"/>
         </a:defRPr>
       </a:lvl3pPr>
-      <a:lvl4pPr marL="1028700" algn="l" defTabSz="685800" rtl="0" eaLnBrk="1" latinLnBrk="1" hangingPunct="1">
-        <a:defRPr sz="1350" kern="1200">
+      <a:lvl4pPr marL="540136" algn="l" defTabSz="360091" rtl="0" eaLnBrk="1" latinLnBrk="1" hangingPunct="1">
+        <a:defRPr sz="709" kern="1200">
           <a:solidFill>
             <a:schemeClr val="tx1"/>
           </a:solidFill>
@@ -2911,8 +3524,8 @@
           <a:cs typeface="+mn-cs"/>
         </a:defRPr>
       </a:lvl4pPr>
-      <a:lvl5pPr marL="1371600" algn="l" defTabSz="685800" rtl="0" eaLnBrk="1" latinLnBrk="1" hangingPunct="1">
-        <a:defRPr sz="1350" kern="1200">
+      <a:lvl5pPr marL="720181" algn="l" defTabSz="360091" rtl="0" eaLnBrk="1" latinLnBrk="1" hangingPunct="1">
+        <a:defRPr sz="709" kern="1200">
           <a:solidFill>
             <a:schemeClr val="tx1"/>
           </a:solidFill>
@@ -2921,8 +3534,8 @@
           <a:cs typeface="+mn-cs"/>
         </a:defRPr>
       </a:lvl5pPr>
-      <a:lvl6pPr marL="1714500" algn="l" defTabSz="685800" rtl="0" eaLnBrk="1" latinLnBrk="1" hangingPunct="1">
-        <a:defRPr sz="1350" kern="1200">
+      <a:lvl6pPr marL="900227" algn="l" defTabSz="360091" rtl="0" eaLnBrk="1" latinLnBrk="1" hangingPunct="1">
+        <a:defRPr sz="709" kern="1200">
           <a:solidFill>
             <a:schemeClr val="tx1"/>
           </a:solidFill>
@@ -2931,8 +3544,8 @@
           <a:cs typeface="+mn-cs"/>
         </a:defRPr>
       </a:lvl6pPr>
-      <a:lvl7pPr marL="2057400" algn="l" defTabSz="685800" rtl="0" eaLnBrk="1" latinLnBrk="1" hangingPunct="1">
-        <a:defRPr sz="1350" kern="1200">
+      <a:lvl7pPr marL="1080272" algn="l" defTabSz="360091" rtl="0" eaLnBrk="1" latinLnBrk="1" hangingPunct="1">
+        <a:defRPr sz="709" kern="1200">
           <a:solidFill>
             <a:schemeClr val="tx1"/>
           </a:solidFill>
@@ -2941,8 +3554,8 @@
           <a:cs typeface="+mn-cs"/>
         </a:defRPr>
       </a:lvl7pPr>
-      <a:lvl8pPr marL="2400300" algn="l" defTabSz="685800" rtl="0" eaLnBrk="1" latinLnBrk="1" hangingPunct="1">
-        <a:defRPr sz="1350" kern="1200">
+      <a:lvl8pPr marL="1260318" algn="l" defTabSz="360091" rtl="0" eaLnBrk="1" latinLnBrk="1" hangingPunct="1">
+        <a:defRPr sz="709" kern="1200">
           <a:solidFill>
             <a:schemeClr val="tx1"/>
           </a:solidFill>
@@ -2951,8 +3564,8 @@
           <a:cs typeface="+mn-cs"/>
         </a:defRPr>
       </a:lvl8pPr>
-      <a:lvl9pPr marL="2743200" algn="l" defTabSz="685800" rtl="0" eaLnBrk="1" latinLnBrk="1" hangingPunct="1">
-        <a:defRPr sz="1350" kern="1200">
+      <a:lvl9pPr marL="1440363" algn="l" defTabSz="360091" rtl="0" eaLnBrk="1" latinLnBrk="1" hangingPunct="1">
+        <a:defRPr sz="709" kern="1200">
           <a:solidFill>
             <a:schemeClr val="tx1"/>
           </a:solidFill>
@@ -2972,8 +3585,8 @@
     <p:bg>
       <p:bgPr>
         <a:solidFill>
-          <a:schemeClr val="bg1">
-            <a:lumMod val="95000"/>
+          <a:schemeClr val="bg2">
+            <a:lumMod val="90000"/>
           </a:schemeClr>
         </a:solidFill>
         <a:effectLst/>
@@ -3015,7 +3628,7 @@
         </p:nvSpPr>
         <p:spPr>
           <a:xfrm>
-            <a:off x="1988840" y="335360"/>
+            <a:off x="25" y="0"/>
             <a:ext cx="3600000" cy="10656608"/>
           </a:xfrm>
           <a:prstGeom prst="rect">
@@ -3049,304 +3662,255 @@
           <a:lstStyle/>
           <a:p>
             <a:pPr algn="ctr"/>
-            <a:endParaRPr lang="ko-KR" altLang="en-US" sz="1801" dirty="0"/>
-          </a:p>
-        </p:txBody>
-      </p:sp>
-      <p:sp>
-        <p:nvSpPr>
-          <p:cNvPr id="5" name="직사각형 4">
+            <a:endParaRPr lang="ko-KR" altLang="en-US" sz="1801"/>
+          </a:p>
+        </p:txBody>
+      </p:sp>
+      <p:grpSp>
+        <p:nvGrpSpPr>
+          <p:cNvPr id="3" name="그룹 2">
             <a:extLst>
               <a:ext uri="{FF2B5EF4-FFF2-40B4-BE49-F238E27FC236}">
-                <a16:creationId xmlns:a16="http://schemas.microsoft.com/office/drawing/2014/main" id="{3998A2A6-0417-5CE9-13B9-05347553BE62}"/>
+                <a16:creationId xmlns:a16="http://schemas.microsoft.com/office/drawing/2014/main" id="{A9A1178B-7B47-DF51-1692-8FF5B82294D0}"/>
               </a:ext>
             </a:extLst>
           </p:cNvPr>
-          <p:cNvSpPr>
-            <a:spLocks/>
-          </p:cNvSpPr>
+          <p:cNvGrpSpPr/>
           <p:nvPr/>
-        </p:nvSpPr>
-        <p:spPr>
+        </p:nvGrpSpPr>
+        <p:grpSpPr>
           <a:xfrm>
-            <a:off x="2175211" y="605800"/>
-            <a:ext cx="3240000" cy="2059200"/>
+            <a:off x="186396" y="270440"/>
+            <a:ext cx="3240360" cy="8736191"/>
+            <a:chOff x="2175211" y="605800"/>
+            <a:chExt cx="3240360" cy="8736191"/>
           </a:xfrm>
-          <a:prstGeom prst="rect">
-            <a:avLst/>
-          </a:prstGeom>
-          <a:solidFill>
-            <a:schemeClr val="bg1"/>
-          </a:solidFill>
-          <a:ln>
+        </p:grpSpPr>
+        <p:sp>
+          <p:nvSpPr>
+            <p:cNvPr id="5" name="직사각형 4">
+              <a:extLst>
+                <a:ext uri="{FF2B5EF4-FFF2-40B4-BE49-F238E27FC236}">
+                  <a16:creationId xmlns:a16="http://schemas.microsoft.com/office/drawing/2014/main" id="{3998A2A6-0417-5CE9-13B9-05347553BE62}"/>
+                </a:ext>
+              </a:extLst>
+            </p:cNvPr>
+            <p:cNvSpPr>
+              <a:spLocks/>
+            </p:cNvSpPr>
+            <p:nvPr/>
+          </p:nvSpPr>
+          <p:spPr>
+            <a:xfrm>
+              <a:off x="2175211" y="605800"/>
+              <a:ext cx="3240000" cy="2059200"/>
+            </a:xfrm>
+            <a:prstGeom prst="rect">
+              <a:avLst/>
+            </a:prstGeom>
             <a:solidFill>
-              <a:schemeClr val="tx1"/>
+              <a:schemeClr val="bg1"/>
             </a:solidFill>
-          </a:ln>
-        </p:spPr>
-        <p:style>
-          <a:lnRef idx="2">
-            <a:schemeClr val="accent1">
-              <a:shade val="15000"/>
-            </a:schemeClr>
-          </a:lnRef>
-          <a:fillRef idx="1">
-            <a:schemeClr val="accent1"/>
-          </a:fillRef>
-          <a:effectRef idx="0">
-            <a:schemeClr val="accent1"/>
-          </a:effectRef>
-          <a:fontRef idx="minor">
-            <a:schemeClr val="lt1"/>
-          </a:fontRef>
-        </p:style>
-        <p:txBody>
-          <a:bodyPr rtlCol="0" anchor="ctr"/>
-          <a:lstStyle/>
-          <a:p>
-            <a:pPr algn="ctr"/>
-            <a:endParaRPr lang="ko-KR" altLang="en-US" sz="1801" dirty="0"/>
-          </a:p>
-        </p:txBody>
-      </p:sp>
-      <p:sp>
-        <p:nvSpPr>
-          <p:cNvPr id="6" name="직사각형 5">
-            <a:extLst>
-              <a:ext uri="{FF2B5EF4-FFF2-40B4-BE49-F238E27FC236}">
-                <a16:creationId xmlns:a16="http://schemas.microsoft.com/office/drawing/2014/main" id="{DA876D69-1F44-6C9C-0C84-0A58D8430460}"/>
-              </a:ext>
-            </a:extLst>
-          </p:cNvPr>
-          <p:cNvSpPr>
-            <a:spLocks/>
-          </p:cNvSpPr>
-          <p:nvPr/>
-        </p:nvSpPr>
-        <p:spPr>
-          <a:xfrm>
-            <a:off x="2175211" y="2831465"/>
-            <a:ext cx="3240000" cy="2059200"/>
-          </a:xfrm>
-          <a:prstGeom prst="rect">
-            <a:avLst/>
-          </a:prstGeom>
-          <a:solidFill>
-            <a:schemeClr val="bg1"/>
-          </a:solidFill>
-          <a:ln>
+            <a:ln>
+              <a:solidFill>
+                <a:schemeClr val="tx1"/>
+              </a:solidFill>
+            </a:ln>
+          </p:spPr>
+          <p:style>
+            <a:lnRef idx="2">
+              <a:schemeClr val="accent1">
+                <a:shade val="15000"/>
+              </a:schemeClr>
+            </a:lnRef>
+            <a:fillRef idx="1">
+              <a:schemeClr val="accent1"/>
+            </a:fillRef>
+            <a:effectRef idx="0">
+              <a:schemeClr val="accent1"/>
+            </a:effectRef>
+            <a:fontRef idx="minor">
+              <a:schemeClr val="lt1"/>
+            </a:fontRef>
+          </p:style>
+          <p:txBody>
+            <a:bodyPr rtlCol="0" anchor="ctr"/>
+            <a:lstStyle/>
+            <a:p>
+              <a:pPr algn="ctr"/>
+              <a:endParaRPr lang="ko-KR" altLang="en-US" sz="1801"/>
+            </a:p>
+          </p:txBody>
+        </p:sp>
+        <p:sp>
+          <p:nvSpPr>
+            <p:cNvPr id="6" name="직사각형 5">
+              <a:extLst>
+                <a:ext uri="{FF2B5EF4-FFF2-40B4-BE49-F238E27FC236}">
+                  <a16:creationId xmlns:a16="http://schemas.microsoft.com/office/drawing/2014/main" id="{DA876D69-1F44-6C9C-0C84-0A58D8430460}"/>
+                </a:ext>
+              </a:extLst>
+            </p:cNvPr>
+            <p:cNvSpPr>
+              <a:spLocks/>
+            </p:cNvSpPr>
+            <p:nvPr/>
+          </p:nvSpPr>
+          <p:spPr>
+            <a:xfrm>
+              <a:off x="2175211" y="2831465"/>
+              <a:ext cx="3240000" cy="2059200"/>
+            </a:xfrm>
+            <a:prstGeom prst="rect">
+              <a:avLst/>
+            </a:prstGeom>
             <a:solidFill>
-              <a:schemeClr val="tx1"/>
+              <a:schemeClr val="bg1"/>
             </a:solidFill>
-          </a:ln>
-        </p:spPr>
-        <p:style>
-          <a:lnRef idx="2">
-            <a:schemeClr val="accent1">
-              <a:shade val="15000"/>
-            </a:schemeClr>
-          </a:lnRef>
-          <a:fillRef idx="1">
-            <a:schemeClr val="accent1"/>
-          </a:fillRef>
-          <a:effectRef idx="0">
-            <a:schemeClr val="accent1"/>
-          </a:effectRef>
-          <a:fontRef idx="minor">
-            <a:schemeClr val="lt1"/>
-          </a:fontRef>
-        </p:style>
-        <p:txBody>
-          <a:bodyPr rtlCol="0" anchor="ctr"/>
-          <a:lstStyle/>
-          <a:p>
-            <a:pPr algn="r"/>
-            <a:endParaRPr lang="ko-KR" altLang="en-US" sz="1801" dirty="0"/>
-          </a:p>
-        </p:txBody>
-      </p:sp>
-      <p:sp>
-        <p:nvSpPr>
-          <p:cNvPr id="8" name="직사각형 7">
-            <a:extLst>
-              <a:ext uri="{FF2B5EF4-FFF2-40B4-BE49-F238E27FC236}">
-                <a16:creationId xmlns:a16="http://schemas.microsoft.com/office/drawing/2014/main" id="{CA0D6EB0-D510-8BE1-FF4F-047D493D2827}"/>
-              </a:ext>
-            </a:extLst>
-          </p:cNvPr>
-          <p:cNvSpPr>
-            <a:spLocks/>
-          </p:cNvSpPr>
-          <p:nvPr/>
-        </p:nvSpPr>
-        <p:spPr>
-          <a:xfrm>
-            <a:off x="2175211" y="5057130"/>
-            <a:ext cx="3240360" cy="2059200"/>
-          </a:xfrm>
-          <a:prstGeom prst="rect">
-            <a:avLst/>
-          </a:prstGeom>
-          <a:solidFill>
-            <a:schemeClr val="bg1"/>
-          </a:solidFill>
-          <a:ln>
+            <a:ln>
+              <a:solidFill>
+                <a:schemeClr val="tx1"/>
+              </a:solidFill>
+            </a:ln>
+          </p:spPr>
+          <p:style>
+            <a:lnRef idx="2">
+              <a:schemeClr val="accent1">
+                <a:shade val="15000"/>
+              </a:schemeClr>
+            </a:lnRef>
+            <a:fillRef idx="1">
+              <a:schemeClr val="accent1"/>
+            </a:fillRef>
+            <a:effectRef idx="0">
+              <a:schemeClr val="accent1"/>
+            </a:effectRef>
+            <a:fontRef idx="minor">
+              <a:schemeClr val="lt1"/>
+            </a:fontRef>
+          </p:style>
+          <p:txBody>
+            <a:bodyPr rtlCol="0" anchor="ctr"/>
+            <a:lstStyle/>
+            <a:p>
+              <a:pPr algn="r"/>
+              <a:endParaRPr lang="ko-KR" altLang="en-US" sz="1801"/>
+            </a:p>
+          </p:txBody>
+        </p:sp>
+        <p:sp>
+          <p:nvSpPr>
+            <p:cNvPr id="8" name="직사각형 7">
+              <a:extLst>
+                <a:ext uri="{FF2B5EF4-FFF2-40B4-BE49-F238E27FC236}">
+                  <a16:creationId xmlns:a16="http://schemas.microsoft.com/office/drawing/2014/main" id="{CA0D6EB0-D510-8BE1-FF4F-047D493D2827}"/>
+                </a:ext>
+              </a:extLst>
+            </p:cNvPr>
+            <p:cNvSpPr>
+              <a:spLocks/>
+            </p:cNvSpPr>
+            <p:nvPr/>
+          </p:nvSpPr>
+          <p:spPr>
+            <a:xfrm>
+              <a:off x="2175211" y="5057130"/>
+              <a:ext cx="3240360" cy="2059200"/>
+            </a:xfrm>
+            <a:prstGeom prst="rect">
+              <a:avLst/>
+            </a:prstGeom>
             <a:solidFill>
-              <a:schemeClr val="tx1"/>
+              <a:schemeClr val="bg1"/>
             </a:solidFill>
-          </a:ln>
-        </p:spPr>
-        <p:style>
-          <a:lnRef idx="2">
-            <a:schemeClr val="accent1">
-              <a:shade val="15000"/>
-            </a:schemeClr>
-          </a:lnRef>
-          <a:fillRef idx="1">
-            <a:schemeClr val="accent1"/>
-          </a:fillRef>
-          <a:effectRef idx="0">
-            <a:schemeClr val="accent1"/>
-          </a:effectRef>
-          <a:fontRef idx="minor">
-            <a:schemeClr val="lt1"/>
-          </a:fontRef>
-        </p:style>
-        <p:txBody>
-          <a:bodyPr rtlCol="0" anchor="ctr"/>
-          <a:lstStyle/>
-          <a:p>
-            <a:pPr algn="r"/>
-            <a:endParaRPr lang="ko-KR" altLang="en-US" sz="1801" dirty="0"/>
-          </a:p>
-        </p:txBody>
-      </p:sp>
-      <p:sp>
-        <p:nvSpPr>
-          <p:cNvPr id="9" name="직사각형 8">
-            <a:extLst>
-              <a:ext uri="{FF2B5EF4-FFF2-40B4-BE49-F238E27FC236}">
-                <a16:creationId xmlns:a16="http://schemas.microsoft.com/office/drawing/2014/main" id="{10605D6D-6B5B-13CA-8FA9-1CE6B432B8D1}"/>
-              </a:ext>
-            </a:extLst>
-          </p:cNvPr>
-          <p:cNvSpPr>
-            <a:spLocks/>
-          </p:cNvSpPr>
-          <p:nvPr/>
-        </p:nvSpPr>
-        <p:spPr>
-          <a:xfrm>
-            <a:off x="2175211" y="7282791"/>
-            <a:ext cx="3240360" cy="2059200"/>
-          </a:xfrm>
-          <a:prstGeom prst="rect">
-            <a:avLst/>
-          </a:prstGeom>
-          <a:solidFill>
-            <a:schemeClr val="bg1"/>
-          </a:solidFill>
-          <a:ln>
+            <a:ln>
+              <a:solidFill>
+                <a:schemeClr val="tx1"/>
+              </a:solidFill>
+            </a:ln>
+          </p:spPr>
+          <p:style>
+            <a:lnRef idx="2">
+              <a:schemeClr val="accent1">
+                <a:shade val="15000"/>
+              </a:schemeClr>
+            </a:lnRef>
+            <a:fillRef idx="1">
+              <a:schemeClr val="accent1"/>
+            </a:fillRef>
+            <a:effectRef idx="0">
+              <a:schemeClr val="accent1"/>
+            </a:effectRef>
+            <a:fontRef idx="minor">
+              <a:schemeClr val="lt1"/>
+            </a:fontRef>
+          </p:style>
+          <p:txBody>
+            <a:bodyPr rtlCol="0" anchor="ctr"/>
+            <a:lstStyle/>
+            <a:p>
+              <a:pPr algn="r"/>
+              <a:endParaRPr lang="ko-KR" altLang="en-US" sz="1801"/>
+            </a:p>
+          </p:txBody>
+        </p:sp>
+        <p:sp>
+          <p:nvSpPr>
+            <p:cNvPr id="9" name="직사각형 8">
+              <a:extLst>
+                <a:ext uri="{FF2B5EF4-FFF2-40B4-BE49-F238E27FC236}">
+                  <a16:creationId xmlns:a16="http://schemas.microsoft.com/office/drawing/2014/main" id="{10605D6D-6B5B-13CA-8FA9-1CE6B432B8D1}"/>
+                </a:ext>
+              </a:extLst>
+            </p:cNvPr>
+            <p:cNvSpPr>
+              <a:spLocks/>
+            </p:cNvSpPr>
+            <p:nvPr/>
+          </p:nvSpPr>
+          <p:spPr>
+            <a:xfrm>
+              <a:off x="2175211" y="7282791"/>
+              <a:ext cx="3240360" cy="2059200"/>
+            </a:xfrm>
+            <a:prstGeom prst="rect">
+              <a:avLst/>
+            </a:prstGeom>
             <a:solidFill>
-              <a:schemeClr val="tx1"/>
+              <a:schemeClr val="bg1"/>
             </a:solidFill>
-          </a:ln>
-        </p:spPr>
-        <p:style>
-          <a:lnRef idx="2">
-            <a:schemeClr val="accent1">
-              <a:shade val="15000"/>
-            </a:schemeClr>
-          </a:lnRef>
-          <a:fillRef idx="1">
-            <a:schemeClr val="accent1"/>
-          </a:fillRef>
-          <a:effectRef idx="0">
-            <a:schemeClr val="accent1"/>
-          </a:effectRef>
-          <a:fontRef idx="minor">
-            <a:schemeClr val="lt1"/>
-          </a:fontRef>
-        </p:style>
-        <p:txBody>
-          <a:bodyPr rtlCol="0" anchor="ctr"/>
-          <a:lstStyle/>
-          <a:p>
-            <a:pPr algn="r"/>
-            <a:endParaRPr lang="ko-KR" altLang="en-US" sz="1801" dirty="0"/>
-          </a:p>
-        </p:txBody>
-      </p:sp>
-      <p:sp>
-        <p:nvSpPr>
-          <p:cNvPr id="15" name="직사각형 14">
-            <a:extLst>
-              <a:ext uri="{FF2B5EF4-FFF2-40B4-BE49-F238E27FC236}">
-                <a16:creationId xmlns:a16="http://schemas.microsoft.com/office/drawing/2014/main" id="{ADE2D373-BCB6-60C6-C0AB-C0A56ADE0221}"/>
-              </a:ext>
-            </a:extLst>
-          </p:cNvPr>
-          <p:cNvSpPr>
-            <a:spLocks noChangeAspect="1"/>
-          </p:cNvSpPr>
-          <p:nvPr/>
-        </p:nvSpPr>
-        <p:spPr>
-          <a:xfrm>
-            <a:off x="2528900" y="9732404"/>
-            <a:ext cx="2514879" cy="757604"/>
-          </a:xfrm>
-          <a:prstGeom prst="rect">
-            <a:avLst/>
-          </a:prstGeom>
-          <a:solidFill>
-            <a:schemeClr val="tx1"/>
-          </a:solidFill>
-          <a:ln>
-            <a:noFill/>
-          </a:ln>
-        </p:spPr>
-        <p:style>
-          <a:lnRef idx="2">
-            <a:schemeClr val="accent1">
-              <a:shade val="15000"/>
-            </a:schemeClr>
-          </a:lnRef>
-          <a:fillRef idx="1">
-            <a:schemeClr val="accent1"/>
-          </a:fillRef>
-          <a:effectRef idx="0">
-            <a:schemeClr val="accent1"/>
-          </a:effectRef>
-          <a:fontRef idx="minor">
-            <a:schemeClr val="lt1"/>
-          </a:fontRef>
-        </p:style>
-        <p:txBody>
-          <a:bodyPr rtlCol="0" anchor="ctr"/>
-          <a:lstStyle/>
-          <a:p>
-            <a:pPr algn="ctr"/>
-            <a:r>
-              <a:rPr lang="ko-KR" altLang="en-US" sz="2400" spc="-150" dirty="0" err="1">
-                <a:solidFill>
-                  <a:schemeClr val="bg1"/>
-                </a:solidFill>
-                <a:latin typeface="ONE 모바일고딕 Title OTF" panose="00000500000000000000" pitchFamily="50" charset="-127"/>
-                <a:ea typeface="ONE 모바일고딕 Title OTF" panose="00000500000000000000" pitchFamily="50" charset="-127"/>
-              </a:rPr>
-              <a:t>용중네컷</a:t>
-            </a:r>
-            <a:endParaRPr lang="ko-KR" altLang="en-US" sz="2800" spc="-150" dirty="0">
+            <a:ln>
               <a:solidFill>
-                <a:schemeClr val="bg1"/>
+                <a:schemeClr val="tx1"/>
               </a:solidFill>
-              <a:latin typeface="ONE 모바일고딕 Title OTF" panose="00000500000000000000" pitchFamily="50" charset="-127"/>
-              <a:ea typeface="ONE 모바일고딕 Title OTF" panose="00000500000000000000" pitchFamily="50" charset="-127"/>
-            </a:endParaRPr>
-          </a:p>
-        </p:txBody>
-      </p:sp>
+            </a:ln>
+          </p:spPr>
+          <p:style>
+            <a:lnRef idx="2">
+              <a:schemeClr val="accent1">
+                <a:shade val="15000"/>
+              </a:schemeClr>
+            </a:lnRef>
+            <a:fillRef idx="1">
+              <a:schemeClr val="accent1"/>
+            </a:fillRef>
+            <a:effectRef idx="0">
+              <a:schemeClr val="accent1"/>
+            </a:effectRef>
+            <a:fontRef idx="minor">
+              <a:schemeClr val="lt1"/>
+            </a:fontRef>
+          </p:style>
+          <p:txBody>
+            <a:bodyPr rtlCol="0" anchor="ctr"/>
+            <a:lstStyle/>
+            <a:p>
+              <a:pPr algn="r"/>
+              <a:endParaRPr lang="ko-KR" altLang="en-US" sz="1801"/>
+            </a:p>
+          </p:txBody>
+        </p:sp>
+      </p:grpSp>
       <p:sp>
         <p:nvSpPr>
           <p:cNvPr id="16" name="직사각형 15">
@@ -3363,7 +3927,7 @@
         </p:nvSpPr>
         <p:spPr>
           <a:xfrm>
-            <a:off x="2528900" y="10308468"/>
+            <a:off x="540086" y="9973108"/>
             <a:ext cx="2514879" cy="236306"/>
           </a:xfrm>
           <a:prstGeom prst="rect">
@@ -3396,22 +3960,71 @@
           <a:p>
             <a:pPr algn="ctr"/>
             <a:r>
-              <a:rPr lang="en-US" altLang="ko-KR" sz="1400" spc="-150" dirty="0">
+              <a:rPr lang="en-US" altLang="ko-KR" sz="1200" spc="-150">
                 <a:solidFill>
                   <a:schemeClr val="bg1"/>
                 </a:solidFill>
-                <a:latin typeface="Harlow Solid Italic" panose="04030604020F02020D02" pitchFamily="82" charset="0"/>
-                <a:ea typeface="HY얕은샘물M" panose="02030600000101010101" pitchFamily="18" charset="-127"/>
+                <a:latin typeface="페이퍼로지 1 Thin" pitchFamily="2" charset="-127"/>
+                <a:ea typeface="페이퍼로지 1 Thin" pitchFamily="2" charset="-127"/>
               </a:rPr>
-              <a:t>20260109</a:t>
-            </a:r>
-            <a:endParaRPr lang="ko-KR" altLang="en-US" sz="2800" spc="-150" dirty="0">
+              <a:t>2026</a:t>
+            </a:r>
+            <a:endParaRPr lang="ko-KR" altLang="en-US" sz="2800" spc="-150">
               <a:solidFill>
                 <a:schemeClr val="bg1"/>
               </a:solidFill>
-              <a:latin typeface="Harlow Solid Italic" panose="04030604020F02020D02" pitchFamily="82" charset="0"/>
-              <a:ea typeface="HY얕은샘물M" panose="02030600000101010101" pitchFamily="18" charset="-127"/>
+              <a:latin typeface="페이퍼로지 1 Thin" pitchFamily="2" charset="-127"/>
+              <a:ea typeface="페이퍼로지 1 Thin" pitchFamily="2" charset="-127"/>
             </a:endParaRPr>
+          </a:p>
+        </p:txBody>
+      </p:sp>
+      <p:sp>
+        <p:nvSpPr>
+          <p:cNvPr id="2" name="제목 1">
+            <a:extLst>
+              <a:ext uri="{FF2B5EF4-FFF2-40B4-BE49-F238E27FC236}">
+                <a16:creationId xmlns:a16="http://schemas.microsoft.com/office/drawing/2014/main" id="{9BF8FEF3-7D80-A3C1-2ED3-C53F85E0F904}"/>
+              </a:ext>
+            </a:extLst>
+          </p:cNvPr>
+          <p:cNvSpPr>
+            <a:spLocks noGrp="1"/>
+          </p:cNvSpPr>
+          <p:nvPr>
+            <p:ph type="ctrTitle"/>
+          </p:nvPr>
+        </p:nvSpPr>
+        <p:spPr>
+          <a:xfrm>
+            <a:off x="680503" y="9402180"/>
+            <a:ext cx="2251787" cy="570928"/>
+          </a:xfrm>
+        </p:spPr>
+        <p:txBody>
+          <a:bodyPr anchor="ctr">
+            <a:normAutofit/>
+          </a:bodyPr>
+          <a:lstStyle/>
+          <a:p>
+            <a:r>
+              <a:rPr lang="ko-KR" altLang="en-US" sz="3200" spc="-300">
+                <a:gradFill>
+                  <a:gsLst>
+                    <a:gs pos="35000">
+                      <a:srgbClr val="FFC000"/>
+                    </a:gs>
+                    <a:gs pos="78000">
+                      <a:schemeClr val="accent2"/>
+                    </a:gs>
+                  </a:gsLst>
+                  <a:lin ang="10800000" scaled="0"/>
+                </a:gradFill>
+                <a:latin typeface="페이퍼로지 1 Thin" pitchFamily="2" charset="-127"/>
+                <a:ea typeface="페이퍼로지 1 Thin" pitchFamily="2" charset="-127"/>
+              </a:rPr>
+              <a:t>용중네컷</a:t>
+            </a:r>
           </a:p>
         </p:txBody>
       </p:sp>
@@ -3434,8 +4047,8 @@
     <p:bg>
       <p:bgPr>
         <a:solidFill>
-          <a:schemeClr val="bg1">
-            <a:lumMod val="95000"/>
+          <a:schemeClr val="bg2">
+            <a:lumMod val="90000"/>
           </a:schemeClr>
         </a:solidFill>
         <a:effectLst/>
@@ -3477,7 +4090,7 @@
         </p:nvSpPr>
         <p:spPr>
           <a:xfrm>
-            <a:off x="1988840" y="335360"/>
+            <a:off x="25" y="-1308"/>
             <a:ext cx="3600000" cy="10656608"/>
           </a:xfrm>
           <a:prstGeom prst="rect">
@@ -3486,7 +4099,7 @@
           <a:solidFill>
             <a:schemeClr val="bg1"/>
           </a:solidFill>
-          <a:ln>
+          <a:ln w="3175">
             <a:noFill/>
           </a:ln>
         </p:spPr>
@@ -3511,319 +4124,272 @@
           <a:lstStyle/>
           <a:p>
             <a:pPr algn="ctr"/>
-            <a:endParaRPr lang="ko-KR" altLang="en-US" sz="1801" dirty="0"/>
-          </a:p>
-        </p:txBody>
-      </p:sp>
-      <p:sp>
-        <p:nvSpPr>
-          <p:cNvPr id="5" name="직사각형 4">
+            <a:endParaRPr lang="ko-KR" altLang="en-US" sz="1801"/>
+          </a:p>
+        </p:txBody>
+      </p:sp>
+      <p:grpSp>
+        <p:nvGrpSpPr>
+          <p:cNvPr id="11" name="그룹 10">
             <a:extLst>
               <a:ext uri="{FF2B5EF4-FFF2-40B4-BE49-F238E27FC236}">
-                <a16:creationId xmlns:a16="http://schemas.microsoft.com/office/drawing/2014/main" id="{84B3A4AB-3D9C-3264-E7D3-2A47686CFDE1}"/>
+                <a16:creationId xmlns:a16="http://schemas.microsoft.com/office/drawing/2014/main" id="{9032AC3F-FA81-6DCE-66E4-DF52E3634A4D}"/>
               </a:ext>
             </a:extLst>
           </p:cNvPr>
-          <p:cNvSpPr>
-            <a:spLocks/>
-          </p:cNvSpPr>
+          <p:cNvGrpSpPr/>
           <p:nvPr/>
-        </p:nvSpPr>
-        <p:spPr>
+        </p:nvGrpSpPr>
+        <p:grpSpPr>
           <a:xfrm>
-            <a:off x="2175211" y="605800"/>
-            <a:ext cx="3240000" cy="2059200"/>
+            <a:off x="179845" y="269132"/>
+            <a:ext cx="3240360" cy="8736191"/>
+            <a:chOff x="2168660" y="605800"/>
+            <a:chExt cx="3240360" cy="8736191"/>
           </a:xfrm>
-          <a:prstGeom prst="rect">
-            <a:avLst/>
-          </a:prstGeom>
-          <a:solidFill>
-            <a:schemeClr val="bg1"/>
-          </a:solidFill>
-          <a:ln>
+        </p:grpSpPr>
+        <p:sp>
+          <p:nvSpPr>
+            <p:cNvPr id="5" name="직사각형 4">
+              <a:extLst>
+                <a:ext uri="{FF2B5EF4-FFF2-40B4-BE49-F238E27FC236}">
+                  <a16:creationId xmlns:a16="http://schemas.microsoft.com/office/drawing/2014/main" id="{84B3A4AB-3D9C-3264-E7D3-2A47686CFDE1}"/>
+                </a:ext>
+              </a:extLst>
+            </p:cNvPr>
+            <p:cNvSpPr>
+              <a:spLocks/>
+            </p:cNvSpPr>
+            <p:nvPr/>
+          </p:nvSpPr>
+          <p:spPr>
+            <a:xfrm>
+              <a:off x="2168840" y="605800"/>
+              <a:ext cx="3240000" cy="2059200"/>
+            </a:xfrm>
+            <a:prstGeom prst="rect">
+              <a:avLst/>
+            </a:prstGeom>
             <a:solidFill>
-              <a:schemeClr val="tx1"/>
+              <a:schemeClr val="bg1"/>
             </a:solidFill>
-          </a:ln>
-        </p:spPr>
-        <p:style>
-          <a:lnRef idx="2">
-            <a:schemeClr val="accent1">
-              <a:shade val="15000"/>
-            </a:schemeClr>
-          </a:lnRef>
-          <a:fillRef idx="1">
-            <a:schemeClr val="accent1"/>
-          </a:fillRef>
-          <a:effectRef idx="0">
-            <a:schemeClr val="accent1"/>
-          </a:effectRef>
-          <a:fontRef idx="minor">
-            <a:schemeClr val="lt1"/>
-          </a:fontRef>
-        </p:style>
-        <p:txBody>
-          <a:bodyPr rtlCol="0" anchor="ctr"/>
-          <a:lstStyle/>
-          <a:p>
-            <a:pPr algn="ctr"/>
-            <a:endParaRPr lang="ko-KR" altLang="en-US" sz="1801" dirty="0"/>
-          </a:p>
-        </p:txBody>
-      </p:sp>
-      <p:sp>
-        <p:nvSpPr>
-          <p:cNvPr id="6" name="직사각형 5">
+            <a:ln w="3175">
+              <a:solidFill>
+                <a:schemeClr val="tx1"/>
+              </a:solidFill>
+            </a:ln>
+          </p:spPr>
+          <p:style>
+            <a:lnRef idx="2">
+              <a:schemeClr val="accent1">
+                <a:shade val="15000"/>
+              </a:schemeClr>
+            </a:lnRef>
+            <a:fillRef idx="1">
+              <a:schemeClr val="accent1"/>
+            </a:fillRef>
+            <a:effectRef idx="0">
+              <a:schemeClr val="accent1"/>
+            </a:effectRef>
+            <a:fontRef idx="minor">
+              <a:schemeClr val="lt1"/>
+            </a:fontRef>
+          </p:style>
+          <p:txBody>
+            <a:bodyPr rtlCol="0" anchor="ctr"/>
+            <a:lstStyle/>
+            <a:p>
+              <a:pPr algn="ctr"/>
+              <a:endParaRPr lang="ko-KR" altLang="en-US" sz="1801"/>
+            </a:p>
+          </p:txBody>
+        </p:sp>
+        <p:sp>
+          <p:nvSpPr>
+            <p:cNvPr id="6" name="직사각형 5">
+              <a:extLst>
+                <a:ext uri="{FF2B5EF4-FFF2-40B4-BE49-F238E27FC236}">
+                  <a16:creationId xmlns:a16="http://schemas.microsoft.com/office/drawing/2014/main" id="{40E52DAE-69EC-D172-5700-E3AFC72B555C}"/>
+                </a:ext>
+              </a:extLst>
+            </p:cNvPr>
+            <p:cNvSpPr>
+              <a:spLocks/>
+            </p:cNvSpPr>
+            <p:nvPr/>
+          </p:nvSpPr>
+          <p:spPr>
+            <a:xfrm>
+              <a:off x="2168840" y="2831465"/>
+              <a:ext cx="3240000" cy="2059200"/>
+            </a:xfrm>
+            <a:prstGeom prst="rect">
+              <a:avLst/>
+            </a:prstGeom>
+            <a:solidFill>
+              <a:schemeClr val="bg1"/>
+            </a:solidFill>
+            <a:ln w="3175">
+              <a:solidFill>
+                <a:schemeClr val="tx1"/>
+              </a:solidFill>
+            </a:ln>
+          </p:spPr>
+          <p:style>
+            <a:lnRef idx="2">
+              <a:schemeClr val="accent1">
+                <a:shade val="15000"/>
+              </a:schemeClr>
+            </a:lnRef>
+            <a:fillRef idx="1">
+              <a:schemeClr val="accent1"/>
+            </a:fillRef>
+            <a:effectRef idx="0">
+              <a:schemeClr val="accent1"/>
+            </a:effectRef>
+            <a:fontRef idx="minor">
+              <a:schemeClr val="lt1"/>
+            </a:fontRef>
+          </p:style>
+          <p:txBody>
+            <a:bodyPr rtlCol="0" anchor="ctr"/>
+            <a:lstStyle/>
+            <a:p>
+              <a:pPr algn="r"/>
+              <a:endParaRPr lang="ko-KR" altLang="en-US" sz="1801"/>
+            </a:p>
+          </p:txBody>
+        </p:sp>
+        <p:sp>
+          <p:nvSpPr>
+            <p:cNvPr id="8" name="직사각형 7">
+              <a:extLst>
+                <a:ext uri="{FF2B5EF4-FFF2-40B4-BE49-F238E27FC236}">
+                  <a16:creationId xmlns:a16="http://schemas.microsoft.com/office/drawing/2014/main" id="{FE979DDF-76C7-0831-96B7-468DE5544D79}"/>
+                </a:ext>
+              </a:extLst>
+            </p:cNvPr>
+            <p:cNvSpPr>
+              <a:spLocks/>
+            </p:cNvSpPr>
+            <p:nvPr/>
+          </p:nvSpPr>
+          <p:spPr>
+            <a:xfrm>
+              <a:off x="2168660" y="5057130"/>
+              <a:ext cx="3240360" cy="2059200"/>
+            </a:xfrm>
+            <a:prstGeom prst="rect">
+              <a:avLst/>
+            </a:prstGeom>
+            <a:solidFill>
+              <a:schemeClr val="bg1"/>
+            </a:solidFill>
+            <a:ln w="3175">
+              <a:solidFill>
+                <a:schemeClr val="tx1"/>
+              </a:solidFill>
+            </a:ln>
+          </p:spPr>
+          <p:style>
+            <a:lnRef idx="2">
+              <a:schemeClr val="accent1">
+                <a:shade val="15000"/>
+              </a:schemeClr>
+            </a:lnRef>
+            <a:fillRef idx="1">
+              <a:schemeClr val="accent1"/>
+            </a:fillRef>
+            <a:effectRef idx="0">
+              <a:schemeClr val="accent1"/>
+            </a:effectRef>
+            <a:fontRef idx="minor">
+              <a:schemeClr val="lt1"/>
+            </a:fontRef>
+          </p:style>
+          <p:txBody>
+            <a:bodyPr rtlCol="0" anchor="ctr"/>
+            <a:lstStyle/>
+            <a:p>
+              <a:pPr algn="r"/>
+              <a:endParaRPr lang="ko-KR" altLang="en-US" sz="1801"/>
+            </a:p>
+          </p:txBody>
+        </p:sp>
+        <p:sp>
+          <p:nvSpPr>
+            <p:cNvPr id="9" name="직사각형 8">
+              <a:extLst>
+                <a:ext uri="{FF2B5EF4-FFF2-40B4-BE49-F238E27FC236}">
+                  <a16:creationId xmlns:a16="http://schemas.microsoft.com/office/drawing/2014/main" id="{866EB5E5-194E-36F1-0A4F-BE693D1826EA}"/>
+                </a:ext>
+              </a:extLst>
+            </p:cNvPr>
+            <p:cNvSpPr>
+              <a:spLocks/>
+            </p:cNvSpPr>
+            <p:nvPr/>
+          </p:nvSpPr>
+          <p:spPr>
+            <a:xfrm>
+              <a:off x="2168660" y="7282791"/>
+              <a:ext cx="3240360" cy="2059200"/>
+            </a:xfrm>
+            <a:prstGeom prst="rect">
+              <a:avLst/>
+            </a:prstGeom>
+            <a:solidFill>
+              <a:schemeClr val="bg1"/>
+            </a:solidFill>
+            <a:ln w="3175">
+              <a:solidFill>
+                <a:schemeClr val="tx1"/>
+              </a:solidFill>
+            </a:ln>
+          </p:spPr>
+          <p:style>
+            <a:lnRef idx="2">
+              <a:schemeClr val="accent1">
+                <a:shade val="15000"/>
+              </a:schemeClr>
+            </a:lnRef>
+            <a:fillRef idx="1">
+              <a:schemeClr val="accent1"/>
+            </a:fillRef>
+            <a:effectRef idx="0">
+              <a:schemeClr val="accent1"/>
+            </a:effectRef>
+            <a:fontRef idx="minor">
+              <a:schemeClr val="lt1"/>
+            </a:fontRef>
+          </p:style>
+          <p:txBody>
+            <a:bodyPr rtlCol="0" anchor="ctr"/>
+            <a:lstStyle/>
+            <a:p>
+              <a:pPr algn="r"/>
+              <a:endParaRPr lang="ko-KR" altLang="en-US" sz="1801"/>
+            </a:p>
+          </p:txBody>
+        </p:sp>
+      </p:grpSp>
+      <p:sp>
+        <p:nvSpPr>
+          <p:cNvPr id="7" name="직사각형 6">
             <a:extLst>
               <a:ext uri="{FF2B5EF4-FFF2-40B4-BE49-F238E27FC236}">
-                <a16:creationId xmlns:a16="http://schemas.microsoft.com/office/drawing/2014/main" id="{40E52DAE-69EC-D172-5700-E3AFC72B555C}"/>
+                <a16:creationId xmlns:a16="http://schemas.microsoft.com/office/drawing/2014/main" id="{B6CD9D7D-3F63-F239-524F-5FF785E4E82C}"/>
               </a:ext>
             </a:extLst>
           </p:cNvPr>
           <p:cNvSpPr>
-            <a:spLocks/>
+            <a:spLocks noChangeAspect="1"/>
           </p:cNvSpPr>
           <p:nvPr/>
         </p:nvSpPr>
         <p:spPr>
           <a:xfrm>
-            <a:off x="2175211" y="2831465"/>
-            <a:ext cx="3240000" cy="2059200"/>
-          </a:xfrm>
-          <a:prstGeom prst="rect">
-            <a:avLst/>
-          </a:prstGeom>
-          <a:solidFill>
-            <a:schemeClr val="bg1"/>
-          </a:solidFill>
-          <a:ln>
-            <a:solidFill>
-              <a:schemeClr val="tx1"/>
-            </a:solidFill>
-          </a:ln>
-        </p:spPr>
-        <p:style>
-          <a:lnRef idx="2">
-            <a:schemeClr val="accent1">
-              <a:shade val="15000"/>
-            </a:schemeClr>
-          </a:lnRef>
-          <a:fillRef idx="1">
-            <a:schemeClr val="accent1"/>
-          </a:fillRef>
-          <a:effectRef idx="0">
-            <a:schemeClr val="accent1"/>
-          </a:effectRef>
-          <a:fontRef idx="minor">
-            <a:schemeClr val="lt1"/>
-          </a:fontRef>
-        </p:style>
-        <p:txBody>
-          <a:bodyPr rtlCol="0" anchor="ctr"/>
-          <a:lstStyle/>
-          <a:p>
-            <a:pPr algn="r"/>
-            <a:endParaRPr lang="ko-KR" altLang="en-US" sz="1801" dirty="0"/>
-          </a:p>
-        </p:txBody>
-      </p:sp>
-      <p:sp>
-        <p:nvSpPr>
-          <p:cNvPr id="8" name="직사각형 7">
-            <a:extLst>
-              <a:ext uri="{FF2B5EF4-FFF2-40B4-BE49-F238E27FC236}">
-                <a16:creationId xmlns:a16="http://schemas.microsoft.com/office/drawing/2014/main" id="{FE979DDF-76C7-0831-96B7-468DE5544D79}"/>
-              </a:ext>
-            </a:extLst>
-          </p:cNvPr>
-          <p:cNvSpPr>
-            <a:spLocks/>
-          </p:cNvSpPr>
-          <p:nvPr/>
-        </p:nvSpPr>
-        <p:spPr>
-          <a:xfrm>
-            <a:off x="2175211" y="5057130"/>
-            <a:ext cx="3240360" cy="2059200"/>
-          </a:xfrm>
-          <a:prstGeom prst="rect">
-            <a:avLst/>
-          </a:prstGeom>
-          <a:solidFill>
-            <a:schemeClr val="bg1"/>
-          </a:solidFill>
-          <a:ln>
-            <a:solidFill>
-              <a:schemeClr val="tx1"/>
-            </a:solidFill>
-          </a:ln>
-        </p:spPr>
-        <p:style>
-          <a:lnRef idx="2">
-            <a:schemeClr val="accent1">
-              <a:shade val="15000"/>
-            </a:schemeClr>
-          </a:lnRef>
-          <a:fillRef idx="1">
-            <a:schemeClr val="accent1"/>
-          </a:fillRef>
-          <a:effectRef idx="0">
-            <a:schemeClr val="accent1"/>
-          </a:effectRef>
-          <a:fontRef idx="minor">
-            <a:schemeClr val="lt1"/>
-          </a:fontRef>
-        </p:style>
-        <p:txBody>
-          <a:bodyPr rtlCol="0" anchor="ctr"/>
-          <a:lstStyle/>
-          <a:p>
-            <a:pPr algn="r"/>
-            <a:endParaRPr lang="ko-KR" altLang="en-US" sz="1801" dirty="0"/>
-          </a:p>
-        </p:txBody>
-      </p:sp>
-      <p:sp>
-        <p:nvSpPr>
-          <p:cNvPr id="9" name="직사각형 8">
-            <a:extLst>
-              <a:ext uri="{FF2B5EF4-FFF2-40B4-BE49-F238E27FC236}">
-                <a16:creationId xmlns:a16="http://schemas.microsoft.com/office/drawing/2014/main" id="{866EB5E5-194E-36F1-0A4F-BE693D1826EA}"/>
-              </a:ext>
-            </a:extLst>
-          </p:cNvPr>
-          <p:cNvSpPr>
-            <a:spLocks/>
-          </p:cNvSpPr>
-          <p:nvPr/>
-        </p:nvSpPr>
-        <p:spPr>
-          <a:xfrm>
-            <a:off x="2175211" y="7282791"/>
-            <a:ext cx="3240360" cy="2059200"/>
-          </a:xfrm>
-          <a:prstGeom prst="rect">
-            <a:avLst/>
-          </a:prstGeom>
-          <a:solidFill>
-            <a:schemeClr val="bg1"/>
-          </a:solidFill>
-          <a:ln>
-            <a:solidFill>
-              <a:schemeClr val="tx1"/>
-            </a:solidFill>
-          </a:ln>
-        </p:spPr>
-        <p:style>
-          <a:lnRef idx="2">
-            <a:schemeClr val="accent1">
-              <a:shade val="15000"/>
-            </a:schemeClr>
-          </a:lnRef>
-          <a:fillRef idx="1">
-            <a:schemeClr val="accent1"/>
-          </a:fillRef>
-          <a:effectRef idx="0">
-            <a:schemeClr val="accent1"/>
-          </a:effectRef>
-          <a:fontRef idx="minor">
-            <a:schemeClr val="lt1"/>
-          </a:fontRef>
-        </p:style>
-        <p:txBody>
-          <a:bodyPr rtlCol="0" anchor="ctr"/>
-          <a:lstStyle/>
-          <a:p>
-            <a:pPr algn="r"/>
-            <a:endParaRPr lang="ko-KR" altLang="en-US" sz="1801" dirty="0"/>
-          </a:p>
-        </p:txBody>
-      </p:sp>
-      <p:sp>
-        <p:nvSpPr>
-          <p:cNvPr id="15" name="직사각형 14">
-            <a:extLst>
-              <a:ext uri="{FF2B5EF4-FFF2-40B4-BE49-F238E27FC236}">
-                <a16:creationId xmlns:a16="http://schemas.microsoft.com/office/drawing/2014/main" id="{A7AAE446-E984-6884-8A43-1B48030AA462}"/>
-              </a:ext>
-            </a:extLst>
-          </p:cNvPr>
-          <p:cNvSpPr>
-            <a:spLocks noChangeAspect="1"/>
-          </p:cNvSpPr>
-          <p:nvPr/>
-        </p:nvSpPr>
-        <p:spPr>
-          <a:xfrm>
-            <a:off x="2528900" y="9732404"/>
-            <a:ext cx="2514879" cy="757604"/>
-          </a:xfrm>
-          <a:prstGeom prst="rect">
-            <a:avLst/>
-          </a:prstGeom>
-          <a:noFill/>
-          <a:ln>
-            <a:noFill/>
-          </a:ln>
-        </p:spPr>
-        <p:style>
-          <a:lnRef idx="2">
-            <a:schemeClr val="accent1">
-              <a:shade val="15000"/>
-            </a:schemeClr>
-          </a:lnRef>
-          <a:fillRef idx="1">
-            <a:schemeClr val="accent1"/>
-          </a:fillRef>
-          <a:effectRef idx="0">
-            <a:schemeClr val="accent1"/>
-          </a:effectRef>
-          <a:fontRef idx="minor">
-            <a:schemeClr val="lt1"/>
-          </a:fontRef>
-        </p:style>
-        <p:txBody>
-          <a:bodyPr rtlCol="0" anchor="ctr"/>
-          <a:lstStyle/>
-          <a:p>
-            <a:pPr algn="ctr"/>
-            <a:r>
-              <a:rPr lang="ko-KR" altLang="en-US" sz="2400" spc="-150" dirty="0" err="1">
-                <a:solidFill>
-                  <a:schemeClr val="tx1"/>
-                </a:solidFill>
-                <a:latin typeface="ONE 모바일고딕 Title OTF" panose="00000500000000000000" pitchFamily="50" charset="-127"/>
-                <a:ea typeface="ONE 모바일고딕 Title OTF" panose="00000500000000000000" pitchFamily="50" charset="-127"/>
-              </a:rPr>
-              <a:t>용중네컷</a:t>
-            </a:r>
-            <a:endParaRPr lang="ko-KR" altLang="en-US" sz="2800" spc="-150" dirty="0">
-              <a:solidFill>
-                <a:schemeClr val="tx1"/>
-              </a:solidFill>
-              <a:latin typeface="ONE 모바일고딕 Title OTF" panose="00000500000000000000" pitchFamily="50" charset="-127"/>
-              <a:ea typeface="ONE 모바일고딕 Title OTF" panose="00000500000000000000" pitchFamily="50" charset="-127"/>
-            </a:endParaRPr>
-          </a:p>
-        </p:txBody>
-      </p:sp>
-      <p:sp>
-        <p:nvSpPr>
-          <p:cNvPr id="16" name="직사각형 15">
-            <a:extLst>
-              <a:ext uri="{FF2B5EF4-FFF2-40B4-BE49-F238E27FC236}">
-                <a16:creationId xmlns:a16="http://schemas.microsoft.com/office/drawing/2014/main" id="{71224366-CBBA-4992-929A-D294A1D0BE61}"/>
-              </a:ext>
-            </a:extLst>
-          </p:cNvPr>
-          <p:cNvSpPr>
-            <a:spLocks noChangeAspect="1"/>
-          </p:cNvSpPr>
-          <p:nvPr/>
-        </p:nvSpPr>
-        <p:spPr>
-          <a:xfrm>
-            <a:off x="2528900" y="10308468"/>
+            <a:off x="542587" y="9971800"/>
             <a:ext cx="2514879" cy="236306"/>
           </a:xfrm>
           <a:prstGeom prst="rect">
@@ -3856,21 +4422,85 @@
           <a:p>
             <a:pPr algn="ctr"/>
             <a:r>
-              <a:rPr lang="en-US" altLang="ko-KR" sz="1400" spc="-150" dirty="0">
+              <a:rPr lang="en-US" altLang="ko-KR" sz="1200" spc="-150">
                 <a:solidFill>
                   <a:schemeClr val="tx1"/>
                 </a:solidFill>
-                <a:latin typeface="Harlow Solid Italic" panose="04030604020F02020D02" pitchFamily="82" charset="0"/>
-                <a:ea typeface="HY얕은샘물M" panose="02030600000101010101" pitchFamily="18" charset="-127"/>
+                <a:latin typeface="페이퍼로지 1 Thin" pitchFamily="2" charset="-127"/>
+                <a:ea typeface="페이퍼로지 1 Thin" pitchFamily="2" charset="-127"/>
               </a:rPr>
-              <a:t>20260109</a:t>
-            </a:r>
-            <a:endParaRPr lang="ko-KR" altLang="en-US" sz="2800" spc="-150" dirty="0">
+              <a:t>2026</a:t>
+            </a:r>
+            <a:endParaRPr lang="ko-KR" altLang="en-US" sz="2800" spc="-150">
               <a:solidFill>
                 <a:schemeClr val="tx1"/>
               </a:solidFill>
-              <a:latin typeface="Harlow Solid Italic" panose="04030604020F02020D02" pitchFamily="82" charset="0"/>
-              <a:ea typeface="HY얕은샘물M" panose="02030600000101010101" pitchFamily="18" charset="-127"/>
+              <a:latin typeface="페이퍼로지 1 Thin" pitchFamily="2" charset="-127"/>
+              <a:ea typeface="페이퍼로지 1 Thin" pitchFamily="2" charset="-127"/>
+            </a:endParaRPr>
+          </a:p>
+        </p:txBody>
+      </p:sp>
+      <p:sp>
+        <p:nvSpPr>
+          <p:cNvPr id="10" name="제목 1">
+            <a:extLst>
+              <a:ext uri="{FF2B5EF4-FFF2-40B4-BE49-F238E27FC236}">
+                <a16:creationId xmlns:a16="http://schemas.microsoft.com/office/drawing/2014/main" id="{6F099D59-0A31-F6F1-AC69-7548F0C1D4F9}"/>
+              </a:ext>
+            </a:extLst>
+          </p:cNvPr>
+          <p:cNvSpPr>
+            <a:spLocks noGrp="1"/>
+          </p:cNvSpPr>
+          <p:nvPr>
+            <p:ph type="ctrTitle"/>
+          </p:nvPr>
+        </p:nvSpPr>
+        <p:spPr>
+          <a:xfrm>
+            <a:off x="674133" y="9400872"/>
+            <a:ext cx="2251787" cy="570928"/>
+          </a:xfrm>
+        </p:spPr>
+        <p:txBody>
+          <a:bodyPr anchor="ctr">
+            <a:normAutofit/>
+          </a:bodyPr>
+          <a:lstStyle/>
+          <a:p>
+            <a:r>
+              <a:rPr lang="ko-KR" altLang="en-US" sz="3200" spc="-300" err="1">
+                <a:gradFill>
+                  <a:gsLst>
+                    <a:gs pos="35000">
+                      <a:srgbClr val="FFC000"/>
+                    </a:gs>
+                    <a:gs pos="78000">
+                      <a:schemeClr val="accent2"/>
+                    </a:gs>
+                  </a:gsLst>
+                  <a:lin ang="10800000" scaled="0"/>
+                </a:gradFill>
+                <a:latin typeface="페이퍼로지 1 Thin" pitchFamily="2" charset="-127"/>
+                <a:ea typeface="페이퍼로지 1 Thin" pitchFamily="2" charset="-127"/>
+              </a:rPr>
+              <a:t>용중네컷</a:t>
+            </a:r>
+            <a:endParaRPr lang="ko-KR" altLang="en-US" sz="3200" spc="-300">
+              <a:gradFill>
+                <a:gsLst>
+                  <a:gs pos="35000">
+                    <a:srgbClr val="FFC000"/>
+                  </a:gs>
+                  <a:gs pos="78000">
+                    <a:schemeClr val="accent2"/>
+                  </a:gs>
+                </a:gsLst>
+                <a:lin ang="10800000" scaled="0"/>
+              </a:gradFill>
+              <a:latin typeface="페이퍼로지 1 Thin" pitchFamily="2" charset="-127"/>
+              <a:ea typeface="페이퍼로지 1 Thin" pitchFamily="2" charset="-127"/>
             </a:endParaRPr>
           </a:p>
         </p:txBody>
@@ -3888,10 +4518,921 @@
 </p:sld>
 </file>
 
+<file path=ppt/slides/slide3.xml><?xml version="1.0" encoding="utf-8"?>
+<p:sld xmlns:a="http://schemas.openxmlformats.org/drawingml/2006/main" xmlns:r="http://schemas.openxmlformats.org/officeDocument/2006/relationships" xmlns:p="http://schemas.openxmlformats.org/presentationml/2006/main">
+  <p:cSld>
+    <p:spTree>
+      <p:nvGrpSpPr>
+        <p:cNvPr id="1" name="">
+          <a:extLst>
+            <a:ext uri="{FF2B5EF4-FFF2-40B4-BE49-F238E27FC236}">
+              <a16:creationId xmlns:a16="http://schemas.microsoft.com/office/drawing/2014/main" id="{EE5E708E-8F28-4FAF-C1D6-55E0E1755995}"/>
+            </a:ext>
+          </a:extLst>
+        </p:cNvPr>
+        <p:cNvGrpSpPr/>
+        <p:nvPr/>
+      </p:nvGrpSpPr>
+      <p:grpSpPr>
+        <a:xfrm>
+          <a:off x="0" y="0"/>
+          <a:ext cx="0" cy="0"/>
+          <a:chOff x="0" y="0"/>
+          <a:chExt cx="0" cy="0"/>
+        </a:xfrm>
+      </p:grpSpPr>
+      <p:pic>
+        <p:nvPicPr>
+          <p:cNvPr id="14" name="그림 13" descr="인형, 핑크, 인간의 얼굴, 소녀이(가) 표시된 사진&#10;&#10;AI 생성 콘텐츠는 정확하지 않을 수 있습니다.">
+            <a:extLst>
+              <a:ext uri="{FF2B5EF4-FFF2-40B4-BE49-F238E27FC236}">
+                <a16:creationId xmlns:a16="http://schemas.microsoft.com/office/drawing/2014/main" id="{34EC436C-03AD-4698-4F74-ABA553C14AC4}"/>
+              </a:ext>
+            </a:extLst>
+          </p:cNvPr>
+          <p:cNvPicPr>
+            <a:picLocks noChangeAspect="1"/>
+          </p:cNvPicPr>
+          <p:nvPr/>
+        </p:nvPicPr>
+        <p:blipFill rotWithShape="1">
+          <a:blip r:embed="rId3">
+            <a:extLst>
+              <a:ext uri="{28A0092B-C50C-407E-A947-70E740481C1C}">
+                <a14:useLocalDpi xmlns:a14="http://schemas.microsoft.com/office/drawing/2010/main" val="0"/>
+              </a:ext>
+            </a:extLst>
+          </a:blip>
+          <a:srcRect l="42099" r="15706" b="6746"/>
+          <a:stretch>
+            <a:fillRect/>
+          </a:stretch>
+        </p:blipFill>
+        <p:spPr>
+          <a:xfrm>
+            <a:off x="0" y="2123294"/>
+            <a:ext cx="3600450" cy="8532006"/>
+          </a:xfrm>
+          <a:prstGeom prst="rect">
+            <a:avLst/>
+          </a:prstGeom>
+        </p:spPr>
+      </p:pic>
+      <p:pic>
+        <p:nvPicPr>
+          <p:cNvPr id="19" name="그림 18" descr="인형, 핑크, 인간의 얼굴, 소녀이(가) 표시된 사진&#10;&#10;AI 생성 콘텐츠는 정확하지 않을 수 있습니다.">
+            <a:extLst>
+              <a:ext uri="{FF2B5EF4-FFF2-40B4-BE49-F238E27FC236}">
+                <a16:creationId xmlns:a16="http://schemas.microsoft.com/office/drawing/2014/main" id="{E74B7D52-2B1B-1E07-5401-9315EAAD20A7}"/>
+              </a:ext>
+            </a:extLst>
+          </p:cNvPr>
+          <p:cNvPicPr>
+            <a:picLocks noChangeAspect="1"/>
+          </p:cNvPicPr>
+          <p:nvPr/>
+        </p:nvPicPr>
+        <p:blipFill rotWithShape="1">
+          <a:blip r:embed="rId3">
+            <a:extLst>
+              <a:ext uri="{28A0092B-C50C-407E-A947-70E740481C1C}">
+                <a14:useLocalDpi xmlns:a14="http://schemas.microsoft.com/office/drawing/2010/main" val="0"/>
+              </a:ext>
+            </a:extLst>
+          </a:blip>
+          <a:srcRect l="42099" r="15706" b="89966"/>
+          <a:stretch>
+            <a:fillRect/>
+          </a:stretch>
+        </p:blipFill>
+        <p:spPr>
+          <a:xfrm>
+            <a:off x="0" y="0"/>
+            <a:ext cx="3600450" cy="3041297"/>
+          </a:xfrm>
+          <a:prstGeom prst="rect">
+            <a:avLst/>
+          </a:prstGeom>
+        </p:spPr>
+      </p:pic>
+      <p:grpSp>
+        <p:nvGrpSpPr>
+          <p:cNvPr id="16" name="그룹 15">
+            <a:extLst>
+              <a:ext uri="{FF2B5EF4-FFF2-40B4-BE49-F238E27FC236}">
+                <a16:creationId xmlns:a16="http://schemas.microsoft.com/office/drawing/2014/main" id="{5537F9DF-8867-0C3E-976E-5BDA62E4250B}"/>
+              </a:ext>
+            </a:extLst>
+          </p:cNvPr>
+          <p:cNvGrpSpPr/>
+          <p:nvPr/>
+        </p:nvGrpSpPr>
+        <p:grpSpPr>
+          <a:xfrm>
+            <a:off x="179845" y="254538"/>
+            <a:ext cx="3240360" cy="8736191"/>
+            <a:chOff x="2168660" y="605800"/>
+            <a:chExt cx="3240360" cy="8736191"/>
+          </a:xfrm>
+        </p:grpSpPr>
+        <p:sp>
+          <p:nvSpPr>
+            <p:cNvPr id="5" name="직사각형 4">
+              <a:extLst>
+                <a:ext uri="{FF2B5EF4-FFF2-40B4-BE49-F238E27FC236}">
+                  <a16:creationId xmlns:a16="http://schemas.microsoft.com/office/drawing/2014/main" id="{C187F462-A7C7-1CB9-DB17-A854AFC6E4B0}"/>
+                </a:ext>
+              </a:extLst>
+            </p:cNvPr>
+            <p:cNvSpPr>
+              <a:spLocks/>
+            </p:cNvSpPr>
+            <p:nvPr/>
+          </p:nvSpPr>
+          <p:spPr>
+            <a:xfrm>
+              <a:off x="2168840" y="605800"/>
+              <a:ext cx="3240000" cy="2059200"/>
+            </a:xfrm>
+            <a:prstGeom prst="rect">
+              <a:avLst/>
+            </a:prstGeom>
+            <a:solidFill>
+              <a:schemeClr val="bg1"/>
+            </a:solidFill>
+            <a:ln w="3175">
+              <a:solidFill>
+                <a:schemeClr val="tx1"/>
+              </a:solidFill>
+            </a:ln>
+          </p:spPr>
+          <p:style>
+            <a:lnRef idx="2">
+              <a:schemeClr val="accent1">
+                <a:shade val="15000"/>
+              </a:schemeClr>
+            </a:lnRef>
+            <a:fillRef idx="1">
+              <a:schemeClr val="accent1"/>
+            </a:fillRef>
+            <a:effectRef idx="0">
+              <a:schemeClr val="accent1"/>
+            </a:effectRef>
+            <a:fontRef idx="minor">
+              <a:schemeClr val="lt1"/>
+            </a:fontRef>
+          </p:style>
+          <p:txBody>
+            <a:bodyPr rtlCol="0" anchor="ctr"/>
+            <a:lstStyle/>
+            <a:p>
+              <a:pPr algn="ctr"/>
+              <a:endParaRPr lang="ko-KR" altLang="en-US" sz="1801"/>
+            </a:p>
+          </p:txBody>
+        </p:sp>
+        <p:sp>
+          <p:nvSpPr>
+            <p:cNvPr id="6" name="직사각형 5">
+              <a:extLst>
+                <a:ext uri="{FF2B5EF4-FFF2-40B4-BE49-F238E27FC236}">
+                  <a16:creationId xmlns:a16="http://schemas.microsoft.com/office/drawing/2014/main" id="{F41C9C7C-4279-37C5-E137-4D2303835205}"/>
+                </a:ext>
+              </a:extLst>
+            </p:cNvPr>
+            <p:cNvSpPr>
+              <a:spLocks/>
+            </p:cNvSpPr>
+            <p:nvPr/>
+          </p:nvSpPr>
+          <p:spPr>
+            <a:xfrm>
+              <a:off x="2168840" y="2831465"/>
+              <a:ext cx="3240000" cy="2059200"/>
+            </a:xfrm>
+            <a:prstGeom prst="rect">
+              <a:avLst/>
+            </a:prstGeom>
+            <a:solidFill>
+              <a:schemeClr val="bg1"/>
+            </a:solidFill>
+            <a:ln w="3175">
+              <a:solidFill>
+                <a:schemeClr val="tx1"/>
+              </a:solidFill>
+            </a:ln>
+          </p:spPr>
+          <p:style>
+            <a:lnRef idx="2">
+              <a:schemeClr val="accent1">
+                <a:shade val="15000"/>
+              </a:schemeClr>
+            </a:lnRef>
+            <a:fillRef idx="1">
+              <a:schemeClr val="accent1"/>
+            </a:fillRef>
+            <a:effectRef idx="0">
+              <a:schemeClr val="accent1"/>
+            </a:effectRef>
+            <a:fontRef idx="minor">
+              <a:schemeClr val="lt1"/>
+            </a:fontRef>
+          </p:style>
+          <p:txBody>
+            <a:bodyPr rtlCol="0" anchor="ctr"/>
+            <a:lstStyle/>
+            <a:p>
+              <a:pPr algn="r"/>
+              <a:endParaRPr lang="ko-KR" altLang="en-US" sz="1801"/>
+            </a:p>
+          </p:txBody>
+        </p:sp>
+        <p:sp>
+          <p:nvSpPr>
+            <p:cNvPr id="8" name="직사각형 7">
+              <a:extLst>
+                <a:ext uri="{FF2B5EF4-FFF2-40B4-BE49-F238E27FC236}">
+                  <a16:creationId xmlns:a16="http://schemas.microsoft.com/office/drawing/2014/main" id="{E2EDE103-E9ED-1A8E-2CBC-E86806ACB19F}"/>
+                </a:ext>
+              </a:extLst>
+            </p:cNvPr>
+            <p:cNvSpPr>
+              <a:spLocks/>
+            </p:cNvSpPr>
+            <p:nvPr/>
+          </p:nvSpPr>
+          <p:spPr>
+            <a:xfrm>
+              <a:off x="2168660" y="5057130"/>
+              <a:ext cx="3240360" cy="2059200"/>
+            </a:xfrm>
+            <a:prstGeom prst="rect">
+              <a:avLst/>
+            </a:prstGeom>
+            <a:solidFill>
+              <a:schemeClr val="bg1"/>
+            </a:solidFill>
+            <a:ln w="3175">
+              <a:solidFill>
+                <a:schemeClr val="tx1"/>
+              </a:solidFill>
+            </a:ln>
+          </p:spPr>
+          <p:style>
+            <a:lnRef idx="2">
+              <a:schemeClr val="accent1">
+                <a:shade val="15000"/>
+              </a:schemeClr>
+            </a:lnRef>
+            <a:fillRef idx="1">
+              <a:schemeClr val="accent1"/>
+            </a:fillRef>
+            <a:effectRef idx="0">
+              <a:schemeClr val="accent1"/>
+            </a:effectRef>
+            <a:fontRef idx="minor">
+              <a:schemeClr val="lt1"/>
+            </a:fontRef>
+          </p:style>
+          <p:txBody>
+            <a:bodyPr rtlCol="0" anchor="ctr"/>
+            <a:lstStyle/>
+            <a:p>
+              <a:pPr algn="r"/>
+              <a:endParaRPr lang="ko-KR" altLang="en-US" sz="1801"/>
+            </a:p>
+          </p:txBody>
+        </p:sp>
+        <p:sp>
+          <p:nvSpPr>
+            <p:cNvPr id="9" name="직사각형 8">
+              <a:extLst>
+                <a:ext uri="{FF2B5EF4-FFF2-40B4-BE49-F238E27FC236}">
+                  <a16:creationId xmlns:a16="http://schemas.microsoft.com/office/drawing/2014/main" id="{DBC69780-4906-85D0-C886-B41441081529}"/>
+                </a:ext>
+              </a:extLst>
+            </p:cNvPr>
+            <p:cNvSpPr>
+              <a:spLocks/>
+            </p:cNvSpPr>
+            <p:nvPr/>
+          </p:nvSpPr>
+          <p:spPr>
+            <a:xfrm>
+              <a:off x="2168660" y="7282791"/>
+              <a:ext cx="3240360" cy="2059200"/>
+            </a:xfrm>
+            <a:prstGeom prst="rect">
+              <a:avLst/>
+            </a:prstGeom>
+            <a:solidFill>
+              <a:schemeClr val="bg1"/>
+            </a:solidFill>
+            <a:ln w="3175">
+              <a:solidFill>
+                <a:schemeClr val="tx1"/>
+              </a:solidFill>
+            </a:ln>
+          </p:spPr>
+          <p:style>
+            <a:lnRef idx="2">
+              <a:schemeClr val="accent1">
+                <a:shade val="15000"/>
+              </a:schemeClr>
+            </a:lnRef>
+            <a:fillRef idx="1">
+              <a:schemeClr val="accent1"/>
+            </a:fillRef>
+            <a:effectRef idx="0">
+              <a:schemeClr val="accent1"/>
+            </a:effectRef>
+            <a:fontRef idx="minor">
+              <a:schemeClr val="lt1"/>
+            </a:fontRef>
+          </p:style>
+          <p:txBody>
+            <a:bodyPr rtlCol="0" anchor="ctr"/>
+            <a:lstStyle/>
+            <a:p>
+              <a:pPr algn="r"/>
+              <a:endParaRPr lang="ko-KR" altLang="en-US" sz="1801"/>
+            </a:p>
+          </p:txBody>
+        </p:sp>
+      </p:grpSp>
+      <p:sp>
+        <p:nvSpPr>
+          <p:cNvPr id="7" name="직사각형 6">
+            <a:extLst>
+              <a:ext uri="{FF2B5EF4-FFF2-40B4-BE49-F238E27FC236}">
+                <a16:creationId xmlns:a16="http://schemas.microsoft.com/office/drawing/2014/main" id="{E34D0816-B54B-3438-3125-1B9843F3AE59}"/>
+              </a:ext>
+            </a:extLst>
+          </p:cNvPr>
+          <p:cNvSpPr>
+            <a:spLocks noChangeAspect="1"/>
+          </p:cNvSpPr>
+          <p:nvPr/>
+        </p:nvSpPr>
+        <p:spPr>
+          <a:xfrm>
+            <a:off x="542587" y="9957206"/>
+            <a:ext cx="2514879" cy="236306"/>
+          </a:xfrm>
+          <a:prstGeom prst="rect">
+            <a:avLst/>
+          </a:prstGeom>
+          <a:noFill/>
+          <a:ln>
+            <a:noFill/>
+          </a:ln>
+        </p:spPr>
+        <p:style>
+          <a:lnRef idx="2">
+            <a:schemeClr val="accent1">
+              <a:shade val="15000"/>
+            </a:schemeClr>
+          </a:lnRef>
+          <a:fillRef idx="1">
+            <a:schemeClr val="accent1"/>
+          </a:fillRef>
+          <a:effectRef idx="0">
+            <a:schemeClr val="accent1"/>
+          </a:effectRef>
+          <a:fontRef idx="minor">
+            <a:schemeClr val="lt1"/>
+          </a:fontRef>
+        </p:style>
+        <p:txBody>
+          <a:bodyPr rtlCol="0" anchor="ctr"/>
+          <a:lstStyle/>
+          <a:p>
+            <a:pPr algn="ctr"/>
+            <a:r>
+              <a:rPr lang="en-US" altLang="ko-KR" sz="1200" spc="-150">
+                <a:solidFill>
+                  <a:schemeClr val="bg1"/>
+                </a:solidFill>
+                <a:latin typeface="페이퍼로지 1 Thin" pitchFamily="2" charset="-127"/>
+                <a:ea typeface="페이퍼로지 1 Thin" pitchFamily="2" charset="-127"/>
+              </a:rPr>
+              <a:t>20260225</a:t>
+            </a:r>
+            <a:endParaRPr lang="ko-KR" altLang="en-US" sz="2800" spc="-150">
+              <a:solidFill>
+                <a:schemeClr val="bg1"/>
+              </a:solidFill>
+              <a:latin typeface="페이퍼로지 1 Thin" pitchFamily="2" charset="-127"/>
+              <a:ea typeface="페이퍼로지 1 Thin" pitchFamily="2" charset="-127"/>
+            </a:endParaRPr>
+          </a:p>
+        </p:txBody>
+      </p:sp>
+      <p:sp>
+        <p:nvSpPr>
+          <p:cNvPr id="10" name="제목 1">
+            <a:extLst>
+              <a:ext uri="{FF2B5EF4-FFF2-40B4-BE49-F238E27FC236}">
+                <a16:creationId xmlns:a16="http://schemas.microsoft.com/office/drawing/2014/main" id="{53F0AA05-8843-528D-0C71-094E8D015E1E}"/>
+              </a:ext>
+            </a:extLst>
+          </p:cNvPr>
+          <p:cNvSpPr>
+            <a:spLocks noGrp="1"/>
+          </p:cNvSpPr>
+          <p:nvPr>
+            <p:ph type="ctrTitle"/>
+          </p:nvPr>
+        </p:nvSpPr>
+        <p:spPr>
+          <a:xfrm>
+            <a:off x="674132" y="9386278"/>
+            <a:ext cx="2251787" cy="570928"/>
+          </a:xfrm>
+        </p:spPr>
+        <p:txBody>
+          <a:bodyPr anchor="ctr">
+            <a:normAutofit/>
+          </a:bodyPr>
+          <a:lstStyle/>
+          <a:p>
+            <a:r>
+              <a:rPr lang="ko-KR" altLang="en-US" sz="3200" b="1" spc="-300" err="1">
+                <a:solidFill>
+                  <a:schemeClr val="bg1"/>
+                </a:solidFill>
+                <a:latin typeface="페이퍼로지 1 Thin" pitchFamily="2" charset="-127"/>
+                <a:ea typeface="페이퍼로지 1 Thin" pitchFamily="2" charset="-127"/>
+              </a:rPr>
+              <a:t>용중네컷</a:t>
+            </a:r>
+            <a:endParaRPr lang="ko-KR" altLang="en-US" sz="3200" b="1" spc="-300">
+              <a:solidFill>
+                <a:schemeClr val="bg1"/>
+              </a:solidFill>
+              <a:latin typeface="페이퍼로지 1 Thin" pitchFamily="2" charset="-127"/>
+              <a:ea typeface="페이퍼로지 1 Thin" pitchFamily="2" charset="-127"/>
+            </a:endParaRPr>
+          </a:p>
+        </p:txBody>
+      </p:sp>
+    </p:spTree>
+    <p:extLst>
+      <p:ext uri="{BB962C8B-B14F-4D97-AF65-F5344CB8AC3E}">
+        <p14:creationId xmlns:p14="http://schemas.microsoft.com/office/powerpoint/2010/main" val="2925305064"/>
+      </p:ext>
+    </p:extLst>
+  </p:cSld>
+  <p:clrMapOvr>
+    <a:masterClrMapping/>
+  </p:clrMapOvr>
+</p:sld>
+</file>
+
+<file path=ppt/slides/slide4.xml><?xml version="1.0" encoding="utf-8"?>
+<p:sld xmlns:a="http://schemas.openxmlformats.org/drawingml/2006/main" xmlns:r="http://schemas.openxmlformats.org/officeDocument/2006/relationships" xmlns:p="http://schemas.openxmlformats.org/presentationml/2006/main">
+  <p:cSld>
+    <p:spTree>
+      <p:nvGrpSpPr>
+        <p:cNvPr id="1" name="">
+          <a:extLst>
+            <a:ext uri="{FF2B5EF4-FFF2-40B4-BE49-F238E27FC236}">
+              <a16:creationId xmlns:a16="http://schemas.microsoft.com/office/drawing/2014/main" id="{48124C8B-D506-DBD3-3FBC-F0FA4810BBC9}"/>
+            </a:ext>
+          </a:extLst>
+        </p:cNvPr>
+        <p:cNvGrpSpPr/>
+        <p:nvPr/>
+      </p:nvGrpSpPr>
+      <p:grpSpPr>
+        <a:xfrm>
+          <a:off x="0" y="0"/>
+          <a:ext cx="0" cy="0"/>
+          <a:chOff x="0" y="0"/>
+          <a:chExt cx="0" cy="0"/>
+        </a:xfrm>
+      </p:grpSpPr>
+      <p:sp>
+        <p:nvSpPr>
+          <p:cNvPr id="4" name="직사각형 3">
+            <a:extLst>
+              <a:ext uri="{FF2B5EF4-FFF2-40B4-BE49-F238E27FC236}">
+                <a16:creationId xmlns:a16="http://schemas.microsoft.com/office/drawing/2014/main" id="{84C6A600-FFDE-3E72-0512-601A945F8A7A}"/>
+              </a:ext>
+            </a:extLst>
+          </p:cNvPr>
+          <p:cNvSpPr>
+            <a:spLocks/>
+          </p:cNvSpPr>
+          <p:nvPr/>
+        </p:nvSpPr>
+        <p:spPr>
+          <a:xfrm>
+            <a:off x="25" y="-1308"/>
+            <a:ext cx="3600000" cy="10656608"/>
+          </a:xfrm>
+          <a:prstGeom prst="rect">
+            <a:avLst/>
+          </a:prstGeom>
+          <a:solidFill>
+            <a:srgbClr val="FDDBD9"/>
+          </a:solidFill>
+          <a:ln w="3175">
+            <a:noFill/>
+          </a:ln>
+        </p:spPr>
+        <p:style>
+          <a:lnRef idx="2">
+            <a:schemeClr val="accent1">
+              <a:shade val="15000"/>
+            </a:schemeClr>
+          </a:lnRef>
+          <a:fillRef idx="1">
+            <a:schemeClr val="accent1"/>
+          </a:fillRef>
+          <a:effectRef idx="0">
+            <a:schemeClr val="accent1"/>
+          </a:effectRef>
+          <a:fontRef idx="minor">
+            <a:schemeClr val="lt1"/>
+          </a:fontRef>
+        </p:style>
+        <p:txBody>
+          <a:bodyPr rtlCol="0" anchor="ctr"/>
+          <a:lstStyle/>
+          <a:p>
+            <a:pPr algn="ctr"/>
+            <a:endParaRPr lang="ko-KR" altLang="en-US" sz="1801"/>
+          </a:p>
+        </p:txBody>
+      </p:sp>
+      <p:pic>
+        <p:nvPicPr>
+          <p:cNvPr id="3" name="그림 2" descr="의류, 소년, 인간의 얼굴, 사람이(가) 표시된 사진&#10;&#10;AI 생성 콘텐츠는 정확하지 않을 수 있습니다.">
+            <a:extLst>
+              <a:ext uri="{FF2B5EF4-FFF2-40B4-BE49-F238E27FC236}">
+                <a16:creationId xmlns:a16="http://schemas.microsoft.com/office/drawing/2014/main" id="{E158ED91-B359-B054-7DD9-A65F02CCB14D}"/>
+              </a:ext>
+            </a:extLst>
+          </p:cNvPr>
+          <p:cNvPicPr>
+            <a:picLocks noChangeAspect="1"/>
+          </p:cNvPicPr>
+          <p:nvPr/>
+        </p:nvPicPr>
+        <p:blipFill>
+          <a:blip r:embed="rId3">
+            <a:extLst>
+              <a:ext uri="{28A0092B-C50C-407E-A947-70E740481C1C}">
+                <a14:useLocalDpi xmlns:a14="http://schemas.microsoft.com/office/drawing/2010/main" val="0"/>
+              </a:ext>
+            </a:extLst>
+          </a:blip>
+          <a:srcRect t="1" b="18742"/>
+          <a:stretch>
+            <a:fillRect/>
+          </a:stretch>
+        </p:blipFill>
+        <p:spPr>
+          <a:xfrm>
+            <a:off x="384992" y="8972512"/>
+            <a:ext cx="2830066" cy="1682788"/>
+          </a:xfrm>
+          <a:prstGeom prst="rect">
+            <a:avLst/>
+          </a:prstGeom>
+        </p:spPr>
+      </p:pic>
+      <p:grpSp>
+        <p:nvGrpSpPr>
+          <p:cNvPr id="16" name="그룹 15">
+            <a:extLst>
+              <a:ext uri="{FF2B5EF4-FFF2-40B4-BE49-F238E27FC236}">
+                <a16:creationId xmlns:a16="http://schemas.microsoft.com/office/drawing/2014/main" id="{91F03A2E-A70E-DE04-D6FF-A504FC5885A8}"/>
+              </a:ext>
+            </a:extLst>
+          </p:cNvPr>
+          <p:cNvGrpSpPr/>
+          <p:nvPr/>
+        </p:nvGrpSpPr>
+        <p:grpSpPr>
+          <a:xfrm>
+            <a:off x="179845" y="254538"/>
+            <a:ext cx="3240360" cy="8736191"/>
+            <a:chOff x="2168660" y="605800"/>
+            <a:chExt cx="3240360" cy="8736191"/>
+          </a:xfrm>
+        </p:grpSpPr>
+        <p:sp>
+          <p:nvSpPr>
+            <p:cNvPr id="5" name="직사각형 4">
+              <a:extLst>
+                <a:ext uri="{FF2B5EF4-FFF2-40B4-BE49-F238E27FC236}">
+                  <a16:creationId xmlns:a16="http://schemas.microsoft.com/office/drawing/2014/main" id="{159E47EB-B2FD-F63C-5413-897B0AAC549F}"/>
+                </a:ext>
+              </a:extLst>
+            </p:cNvPr>
+            <p:cNvSpPr>
+              <a:spLocks/>
+            </p:cNvSpPr>
+            <p:nvPr/>
+          </p:nvSpPr>
+          <p:spPr>
+            <a:xfrm>
+              <a:off x="2168840" y="605800"/>
+              <a:ext cx="3240000" cy="2059200"/>
+            </a:xfrm>
+            <a:prstGeom prst="rect">
+              <a:avLst/>
+            </a:prstGeom>
+            <a:solidFill>
+              <a:schemeClr val="bg1"/>
+            </a:solidFill>
+            <a:ln w="3175">
+              <a:solidFill>
+                <a:schemeClr val="tx1"/>
+              </a:solidFill>
+            </a:ln>
+          </p:spPr>
+          <p:style>
+            <a:lnRef idx="2">
+              <a:schemeClr val="accent1">
+                <a:shade val="15000"/>
+              </a:schemeClr>
+            </a:lnRef>
+            <a:fillRef idx="1">
+              <a:schemeClr val="accent1"/>
+            </a:fillRef>
+            <a:effectRef idx="0">
+              <a:schemeClr val="accent1"/>
+            </a:effectRef>
+            <a:fontRef idx="minor">
+              <a:schemeClr val="lt1"/>
+            </a:fontRef>
+          </p:style>
+          <p:txBody>
+            <a:bodyPr rtlCol="0" anchor="ctr"/>
+            <a:lstStyle/>
+            <a:p>
+              <a:pPr algn="ctr"/>
+              <a:endParaRPr lang="ko-KR" altLang="en-US" sz="1801"/>
+            </a:p>
+          </p:txBody>
+        </p:sp>
+        <p:sp>
+          <p:nvSpPr>
+            <p:cNvPr id="6" name="직사각형 5">
+              <a:extLst>
+                <a:ext uri="{FF2B5EF4-FFF2-40B4-BE49-F238E27FC236}">
+                  <a16:creationId xmlns:a16="http://schemas.microsoft.com/office/drawing/2014/main" id="{FFC1F0FE-D74A-5D7D-60FB-DBA9C07F64F7}"/>
+                </a:ext>
+              </a:extLst>
+            </p:cNvPr>
+            <p:cNvSpPr>
+              <a:spLocks/>
+            </p:cNvSpPr>
+            <p:nvPr/>
+          </p:nvSpPr>
+          <p:spPr>
+            <a:xfrm>
+              <a:off x="2168840" y="2831465"/>
+              <a:ext cx="3240000" cy="2059200"/>
+            </a:xfrm>
+            <a:prstGeom prst="rect">
+              <a:avLst/>
+            </a:prstGeom>
+            <a:solidFill>
+              <a:schemeClr val="bg1"/>
+            </a:solidFill>
+            <a:ln w="3175">
+              <a:solidFill>
+                <a:schemeClr val="tx1"/>
+              </a:solidFill>
+            </a:ln>
+          </p:spPr>
+          <p:style>
+            <a:lnRef idx="2">
+              <a:schemeClr val="accent1">
+                <a:shade val="15000"/>
+              </a:schemeClr>
+            </a:lnRef>
+            <a:fillRef idx="1">
+              <a:schemeClr val="accent1"/>
+            </a:fillRef>
+            <a:effectRef idx="0">
+              <a:schemeClr val="accent1"/>
+            </a:effectRef>
+            <a:fontRef idx="minor">
+              <a:schemeClr val="lt1"/>
+            </a:fontRef>
+          </p:style>
+          <p:txBody>
+            <a:bodyPr rtlCol="0" anchor="ctr"/>
+            <a:lstStyle/>
+            <a:p>
+              <a:pPr algn="r"/>
+              <a:endParaRPr lang="ko-KR" altLang="en-US" sz="1801"/>
+            </a:p>
+          </p:txBody>
+        </p:sp>
+        <p:sp>
+          <p:nvSpPr>
+            <p:cNvPr id="8" name="직사각형 7">
+              <a:extLst>
+                <a:ext uri="{FF2B5EF4-FFF2-40B4-BE49-F238E27FC236}">
+                  <a16:creationId xmlns:a16="http://schemas.microsoft.com/office/drawing/2014/main" id="{E576EBB4-83BA-BF9D-C3D5-949E63223502}"/>
+                </a:ext>
+              </a:extLst>
+            </p:cNvPr>
+            <p:cNvSpPr>
+              <a:spLocks/>
+            </p:cNvSpPr>
+            <p:nvPr/>
+          </p:nvSpPr>
+          <p:spPr>
+            <a:xfrm>
+              <a:off x="2168660" y="5057130"/>
+              <a:ext cx="3240360" cy="2059200"/>
+            </a:xfrm>
+            <a:prstGeom prst="rect">
+              <a:avLst/>
+            </a:prstGeom>
+            <a:solidFill>
+              <a:schemeClr val="bg1"/>
+            </a:solidFill>
+            <a:ln w="3175">
+              <a:solidFill>
+                <a:schemeClr val="tx1"/>
+              </a:solidFill>
+            </a:ln>
+          </p:spPr>
+          <p:style>
+            <a:lnRef idx="2">
+              <a:schemeClr val="accent1">
+                <a:shade val="15000"/>
+              </a:schemeClr>
+            </a:lnRef>
+            <a:fillRef idx="1">
+              <a:schemeClr val="accent1"/>
+            </a:fillRef>
+            <a:effectRef idx="0">
+              <a:schemeClr val="accent1"/>
+            </a:effectRef>
+            <a:fontRef idx="minor">
+              <a:schemeClr val="lt1"/>
+            </a:fontRef>
+          </p:style>
+          <p:txBody>
+            <a:bodyPr rtlCol="0" anchor="ctr"/>
+            <a:lstStyle/>
+            <a:p>
+              <a:pPr algn="r"/>
+              <a:endParaRPr lang="ko-KR" altLang="en-US" sz="1801"/>
+            </a:p>
+          </p:txBody>
+        </p:sp>
+        <p:sp>
+          <p:nvSpPr>
+            <p:cNvPr id="9" name="직사각형 8">
+              <a:extLst>
+                <a:ext uri="{FF2B5EF4-FFF2-40B4-BE49-F238E27FC236}">
+                  <a16:creationId xmlns:a16="http://schemas.microsoft.com/office/drawing/2014/main" id="{B70DFDE2-4176-75AF-2576-A39188911770}"/>
+                </a:ext>
+              </a:extLst>
+            </p:cNvPr>
+            <p:cNvSpPr>
+              <a:spLocks/>
+            </p:cNvSpPr>
+            <p:nvPr/>
+          </p:nvSpPr>
+          <p:spPr>
+            <a:xfrm>
+              <a:off x="2168660" y="7282791"/>
+              <a:ext cx="3240360" cy="2059200"/>
+            </a:xfrm>
+            <a:prstGeom prst="rect">
+              <a:avLst/>
+            </a:prstGeom>
+            <a:solidFill>
+              <a:schemeClr val="bg1"/>
+            </a:solidFill>
+            <a:ln w="3175">
+              <a:solidFill>
+                <a:schemeClr val="tx1"/>
+              </a:solidFill>
+            </a:ln>
+          </p:spPr>
+          <p:style>
+            <a:lnRef idx="2">
+              <a:schemeClr val="accent1">
+                <a:shade val="15000"/>
+              </a:schemeClr>
+            </a:lnRef>
+            <a:fillRef idx="1">
+              <a:schemeClr val="accent1"/>
+            </a:fillRef>
+            <a:effectRef idx="0">
+              <a:schemeClr val="accent1"/>
+            </a:effectRef>
+            <a:fontRef idx="minor">
+              <a:schemeClr val="lt1"/>
+            </a:fontRef>
+          </p:style>
+          <p:txBody>
+            <a:bodyPr rtlCol="0" anchor="ctr"/>
+            <a:lstStyle/>
+            <a:p>
+              <a:pPr algn="r"/>
+              <a:endParaRPr lang="ko-KR" altLang="en-US" sz="1801"/>
+            </a:p>
+          </p:txBody>
+        </p:sp>
+      </p:grpSp>
+      <p:sp>
+        <p:nvSpPr>
+          <p:cNvPr id="7" name="직사각형 6">
+            <a:extLst>
+              <a:ext uri="{FF2B5EF4-FFF2-40B4-BE49-F238E27FC236}">
+                <a16:creationId xmlns:a16="http://schemas.microsoft.com/office/drawing/2014/main" id="{B8A7660F-D48B-B01D-5F27-9BF8D75FC800}"/>
+              </a:ext>
+            </a:extLst>
+          </p:cNvPr>
+          <p:cNvSpPr>
+            <a:spLocks noChangeAspect="1"/>
+          </p:cNvSpPr>
+          <p:nvPr/>
+        </p:nvSpPr>
+        <p:spPr>
+          <a:xfrm>
+            <a:off x="1800025" y="10384072"/>
+            <a:ext cx="2514879" cy="236306"/>
+          </a:xfrm>
+          <a:prstGeom prst="rect">
+            <a:avLst/>
+          </a:prstGeom>
+          <a:noFill/>
+          <a:ln>
+            <a:noFill/>
+          </a:ln>
+        </p:spPr>
+        <p:style>
+          <a:lnRef idx="2">
+            <a:schemeClr val="accent1">
+              <a:shade val="15000"/>
+            </a:schemeClr>
+          </a:lnRef>
+          <a:fillRef idx="1">
+            <a:schemeClr val="accent1"/>
+          </a:fillRef>
+          <a:effectRef idx="0">
+            <a:schemeClr val="accent1"/>
+          </a:effectRef>
+          <a:fontRef idx="minor">
+            <a:schemeClr val="lt1"/>
+          </a:fontRef>
+        </p:style>
+        <p:txBody>
+          <a:bodyPr rtlCol="0" anchor="ctr"/>
+          <a:lstStyle/>
+          <a:p>
+            <a:pPr algn="ctr"/>
+            <a:r>
+              <a:rPr lang="en-US" altLang="ko-KR" sz="1200" spc="-150">
+                <a:solidFill>
+                  <a:schemeClr val="tx1"/>
+                </a:solidFill>
+                <a:latin typeface="페이퍼로지 1 Thin" pitchFamily="2" charset="-127"/>
+                <a:ea typeface="페이퍼로지 1 Thin" pitchFamily="2" charset="-127"/>
+              </a:rPr>
+              <a:t>20260225</a:t>
+            </a:r>
+            <a:endParaRPr lang="ko-KR" altLang="en-US" sz="1200" spc="-150">
+              <a:solidFill>
+                <a:schemeClr val="tx1"/>
+              </a:solidFill>
+              <a:latin typeface="페이퍼로지 1 Thin" pitchFamily="2" charset="-127"/>
+              <a:ea typeface="페이퍼로지 1 Thin" pitchFamily="2" charset="-127"/>
+            </a:endParaRPr>
+          </a:p>
+        </p:txBody>
+      </p:sp>
+    </p:spTree>
+    <p:extLst>
+      <p:ext uri="{BB962C8B-B14F-4D97-AF65-F5344CB8AC3E}">
+        <p14:creationId xmlns:p14="http://schemas.microsoft.com/office/powerpoint/2010/main" val="1607153780"/>
+      </p:ext>
+    </p:extLst>
+  </p:cSld>
+  <p:clrMapOvr>
+    <a:masterClrMapping/>
+  </p:clrMapOvr>
+</p:sld>
+</file>
+
 <file path=ppt/theme/theme1.xml><?xml version="1.0" encoding="utf-8"?>
-<a:theme xmlns:a="http://schemas.openxmlformats.org/drawingml/2006/main" name="Office 테마">
+<a:theme xmlns:a="http://schemas.openxmlformats.org/drawingml/2006/main" name="Office 2013 - 2022 테마">
   <a:themeElements>
-    <a:clrScheme name="Office 테마">
+    <a:clrScheme name="Office 2013 - 2022 테마">
       <a:dk1>
         <a:sysClr val="windowText" lastClr="000000"/>
       </a:dk1>
@@ -3929,7 +5470,7 @@
         <a:srgbClr val="954F72"/>
       </a:folHlink>
     </a:clrScheme>
-    <a:fontScheme name="Office 테마">
+    <a:fontScheme name="Office 2013 - 2022 테마">
       <a:majorFont>
         <a:latin typeface="Calibri Light" panose="020F0302020204030204"/>
         <a:ea typeface=""/>
@@ -4001,7 +5542,7 @@
         <a:font script="Geor" typeface="Sylfaen"/>
       </a:minorFont>
     </a:fontScheme>
-    <a:fmtScheme name="Office 테마">
+    <a:fmtScheme name="Office 2013 - 2022 테마">
       <a:fillStyleLst>
         <a:solidFill>
           <a:schemeClr val="phClr"/>
@@ -4147,4 +5688,319 @@
     </a:ext>
   </a:extLst>
 </a:theme>
+</file>
+
+<file path=ppt/theme/theme2.xml><?xml version="1.0" encoding="utf-8"?>
+<a:theme xmlns:a="http://schemas.openxmlformats.org/drawingml/2006/main" name="Office 테마">
+  <a:themeElements>
+    <a:clrScheme name="Office">
+      <a:dk1>
+        <a:sysClr val="windowText" lastClr="000000"/>
+      </a:dk1>
+      <a:lt1>
+        <a:sysClr val="window" lastClr="FFFFFF"/>
+      </a:lt1>
+      <a:dk2>
+        <a:srgbClr val="0E2841"/>
+      </a:dk2>
+      <a:lt2>
+        <a:srgbClr val="E8E8E8"/>
+      </a:lt2>
+      <a:accent1>
+        <a:srgbClr val="156082"/>
+      </a:accent1>
+      <a:accent2>
+        <a:srgbClr val="E97132"/>
+      </a:accent2>
+      <a:accent3>
+        <a:srgbClr val="196B24"/>
+      </a:accent3>
+      <a:accent4>
+        <a:srgbClr val="0F9ED5"/>
+      </a:accent4>
+      <a:accent5>
+        <a:srgbClr val="A02B93"/>
+      </a:accent5>
+      <a:accent6>
+        <a:srgbClr val="4EA72E"/>
+      </a:accent6>
+      <a:hlink>
+        <a:srgbClr val="467886"/>
+      </a:hlink>
+      <a:folHlink>
+        <a:srgbClr val="96607D"/>
+      </a:folHlink>
+    </a:clrScheme>
+    <a:fontScheme name="Office">
+      <a:majorFont>
+        <a:latin typeface="맑은 고딕" panose="02110004020202020204"/>
+        <a:ea typeface=""/>
+        <a:cs typeface=""/>
+        <a:font script="Jpan" typeface="游ゴシック Light"/>
+        <a:font script="Hang" typeface="맑은 고딕"/>
+        <a:font script="Hans" typeface="等线 Light"/>
+        <a:font script="Hant" typeface="新細明體"/>
+        <a:font script="Arab" typeface="Times New Roman"/>
+        <a:font script="Hebr" typeface="Times New Roman"/>
+        <a:font script="Thai" typeface="Angsana New"/>
+        <a:font script="Ethi" typeface="Nyala"/>
+        <a:font script="Beng" typeface="Vrinda"/>
+        <a:font script="Gujr" typeface="Shruti"/>
+        <a:font script="Khmr" typeface="MoolBoran"/>
+        <a:font script="Knda" typeface="Tunga"/>
+        <a:font script="Guru" typeface="Raavi"/>
+        <a:font script="Cans" typeface="Euphemia"/>
+        <a:font script="Cher" typeface="Plantagenet Cherokee"/>
+        <a:font script="Yiii" typeface="Microsoft Yi Baiti"/>
+        <a:font script="Tibt" typeface="Microsoft Himalaya"/>
+        <a:font script="Thaa" typeface="MV Boli"/>
+        <a:font script="Deva" typeface="Mangal"/>
+        <a:font script="Telu" typeface="Gautami"/>
+        <a:font script="Taml" typeface="Latha"/>
+        <a:font script="Syrc" typeface="Estrangelo Edessa"/>
+        <a:font script="Orya" typeface="Kalinga"/>
+        <a:font script="Mlym" typeface="Kartika"/>
+        <a:font script="Laoo" typeface="DokChampa"/>
+        <a:font script="Sinh" typeface="Iskoola Pota"/>
+        <a:font script="Mong" typeface="Mongolian Baiti"/>
+        <a:font script="Viet" typeface="Times New Roman"/>
+        <a:font script="Uigh" typeface="Microsoft Uighur"/>
+        <a:font script="Geor" typeface="Sylfaen"/>
+        <a:font script="Armn" typeface="Arial"/>
+        <a:font script="Bugi" typeface="Leelawadee UI"/>
+        <a:font script="Bopo" typeface="Microsoft JhengHei"/>
+        <a:font script="Java" typeface="Javanese Text"/>
+        <a:font script="Lisu" typeface="Segoe UI"/>
+        <a:font script="Mymr" typeface="Myanmar Text"/>
+        <a:font script="Nkoo" typeface="Ebrima"/>
+        <a:font script="Olck" typeface="Nirmala UI"/>
+        <a:font script="Osma" typeface="Ebrima"/>
+        <a:font script="Phag" typeface="Phagspa"/>
+        <a:font script="Syrn" typeface="Estrangelo Edessa"/>
+        <a:font script="Syrj" typeface="Estrangelo Edessa"/>
+        <a:font script="Syre" typeface="Estrangelo Edessa"/>
+        <a:font script="Sora" typeface="Nirmala UI"/>
+        <a:font script="Tale" typeface="Microsoft Tai Le"/>
+        <a:font script="Talu" typeface="Microsoft New Tai Lue"/>
+        <a:font script="Tfng" typeface="Ebrima"/>
+      </a:majorFont>
+      <a:minorFont>
+        <a:latin typeface="맑은 고딕" panose="02110004020202020204"/>
+        <a:ea typeface=""/>
+        <a:cs typeface=""/>
+        <a:font script="Jpan" typeface="游ゴシック"/>
+        <a:font script="Hang" typeface="맑은 고딕"/>
+        <a:font script="Hans" typeface="等线"/>
+        <a:font script="Hant" typeface="新細明體"/>
+        <a:font script="Arab" typeface="Arial"/>
+        <a:font script="Hebr" typeface="Arial"/>
+        <a:font script="Thai" typeface="Cordia New"/>
+        <a:font script="Ethi" typeface="Nyala"/>
+        <a:font script="Beng" typeface="Vrinda"/>
+        <a:font script="Gujr" typeface="Shruti"/>
+        <a:font script="Khmr" typeface="DaunPenh"/>
+        <a:font script="Knda" typeface="Tunga"/>
+        <a:font script="Guru" typeface="Raavi"/>
+        <a:font script="Cans" typeface="Euphemia"/>
+        <a:font script="Cher" typeface="Plantagenet Cherokee"/>
+        <a:font script="Yiii" typeface="Microsoft Yi Baiti"/>
+        <a:font script="Tibt" typeface="Microsoft Himalaya"/>
+        <a:font script="Thaa" typeface="MV Boli"/>
+        <a:font script="Deva" typeface="Mangal"/>
+        <a:font script="Telu" typeface="Gautami"/>
+        <a:font script="Taml" typeface="Latha"/>
+        <a:font script="Syrc" typeface="Estrangelo Edessa"/>
+        <a:font script="Orya" typeface="Kalinga"/>
+        <a:font script="Mlym" typeface="Kartika"/>
+        <a:font script="Laoo" typeface="DokChampa"/>
+        <a:font script="Sinh" typeface="Iskoola Pota"/>
+        <a:font script="Mong" typeface="Mongolian Baiti"/>
+        <a:font script="Viet" typeface="Arial"/>
+        <a:font script="Uigh" typeface="Microsoft Uighur"/>
+        <a:font script="Geor" typeface="Sylfaen"/>
+        <a:font script="Armn" typeface="Arial"/>
+        <a:font script="Bugi" typeface="Leelawadee UI"/>
+        <a:font script="Bopo" typeface="Microsoft JhengHei"/>
+        <a:font script="Java" typeface="Javanese Text"/>
+        <a:font script="Lisu" typeface="Segoe UI"/>
+        <a:font script="Mymr" typeface="Myanmar Text"/>
+        <a:font script="Nkoo" typeface="Ebrima"/>
+        <a:font script="Olck" typeface="Nirmala UI"/>
+        <a:font script="Osma" typeface="Ebrima"/>
+        <a:font script="Phag" typeface="Phagspa"/>
+        <a:font script="Syrn" typeface="Estrangelo Edessa"/>
+        <a:font script="Syrj" typeface="Estrangelo Edessa"/>
+        <a:font script="Syre" typeface="Estrangelo Edessa"/>
+        <a:font script="Sora" typeface="Nirmala UI"/>
+        <a:font script="Tale" typeface="Microsoft Tai Le"/>
+        <a:font script="Talu" typeface="Microsoft New Tai Lue"/>
+        <a:font script="Tfng" typeface="Ebrima"/>
+      </a:minorFont>
+    </a:fontScheme>
+    <a:fmtScheme name="Office">
+      <a:fillStyleLst>
+        <a:solidFill>
+          <a:schemeClr val="phClr"/>
+        </a:solidFill>
+        <a:gradFill rotWithShape="1">
+          <a:gsLst>
+            <a:gs pos="0">
+              <a:schemeClr val="phClr">
+                <a:lumMod val="110000"/>
+                <a:satMod val="105000"/>
+                <a:tint val="67000"/>
+              </a:schemeClr>
+            </a:gs>
+            <a:gs pos="50000">
+              <a:schemeClr val="phClr">
+                <a:lumMod val="105000"/>
+                <a:satMod val="103000"/>
+                <a:tint val="73000"/>
+              </a:schemeClr>
+            </a:gs>
+            <a:gs pos="100000">
+              <a:schemeClr val="phClr">
+                <a:lumMod val="105000"/>
+                <a:satMod val="109000"/>
+                <a:tint val="81000"/>
+              </a:schemeClr>
+            </a:gs>
+          </a:gsLst>
+          <a:lin ang="5400000" scaled="0"/>
+        </a:gradFill>
+        <a:gradFill rotWithShape="1">
+          <a:gsLst>
+            <a:gs pos="0">
+              <a:schemeClr val="phClr">
+                <a:satMod val="103000"/>
+                <a:lumMod val="102000"/>
+                <a:tint val="94000"/>
+              </a:schemeClr>
+            </a:gs>
+            <a:gs pos="50000">
+              <a:schemeClr val="phClr">
+                <a:satMod val="110000"/>
+                <a:lumMod val="100000"/>
+                <a:shade val="100000"/>
+              </a:schemeClr>
+            </a:gs>
+            <a:gs pos="100000">
+              <a:schemeClr val="phClr">
+                <a:lumMod val="99000"/>
+                <a:satMod val="120000"/>
+                <a:shade val="78000"/>
+              </a:schemeClr>
+            </a:gs>
+          </a:gsLst>
+          <a:lin ang="5400000" scaled="0"/>
+        </a:gradFill>
+      </a:fillStyleLst>
+      <a:lnStyleLst>
+        <a:ln w="12700" cap="flat" cmpd="sng" algn="ctr">
+          <a:solidFill>
+            <a:schemeClr val="phClr"/>
+          </a:solidFill>
+          <a:prstDash val="solid"/>
+          <a:miter lim="800000"/>
+        </a:ln>
+        <a:ln w="19050" cap="flat" cmpd="sng" algn="ctr">
+          <a:solidFill>
+            <a:schemeClr val="phClr"/>
+          </a:solidFill>
+          <a:prstDash val="solid"/>
+          <a:miter lim="800000"/>
+        </a:ln>
+        <a:ln w="25400" cap="flat" cmpd="sng" algn="ctr">
+          <a:solidFill>
+            <a:schemeClr val="phClr"/>
+          </a:solidFill>
+          <a:prstDash val="solid"/>
+          <a:miter lim="800000"/>
+        </a:ln>
+      </a:lnStyleLst>
+      <a:effectStyleLst>
+        <a:effectStyle>
+          <a:effectLst/>
+        </a:effectStyle>
+        <a:effectStyle>
+          <a:effectLst/>
+        </a:effectStyle>
+        <a:effectStyle>
+          <a:effectLst>
+            <a:outerShdw blurRad="57150" dist="19050" dir="5400000" algn="ctr" rotWithShape="0">
+              <a:srgbClr val="000000">
+                <a:alpha val="63000"/>
+              </a:srgbClr>
+            </a:outerShdw>
+          </a:effectLst>
+        </a:effectStyle>
+      </a:effectStyleLst>
+      <a:bgFillStyleLst>
+        <a:solidFill>
+          <a:schemeClr val="phClr"/>
+        </a:solidFill>
+        <a:solidFill>
+          <a:schemeClr val="phClr">
+            <a:tint val="95000"/>
+            <a:satMod val="170000"/>
+          </a:schemeClr>
+        </a:solidFill>
+        <a:gradFill rotWithShape="1">
+          <a:gsLst>
+            <a:gs pos="0">
+              <a:schemeClr val="phClr">
+                <a:tint val="93000"/>
+                <a:satMod val="150000"/>
+                <a:shade val="98000"/>
+                <a:lumMod val="102000"/>
+              </a:schemeClr>
+            </a:gs>
+            <a:gs pos="50000">
+              <a:schemeClr val="phClr">
+                <a:tint val="98000"/>
+                <a:satMod val="130000"/>
+                <a:shade val="90000"/>
+                <a:lumMod val="103000"/>
+              </a:schemeClr>
+            </a:gs>
+            <a:gs pos="100000">
+              <a:schemeClr val="phClr">
+                <a:shade val="63000"/>
+                <a:satMod val="120000"/>
+              </a:schemeClr>
+            </a:gs>
+          </a:gsLst>
+          <a:lin ang="5400000" scaled="0"/>
+        </a:gradFill>
+      </a:bgFillStyleLst>
+    </a:fmtScheme>
+  </a:themeElements>
+  <a:objectDefaults>
+    <a:lnDef>
+      <a:spPr/>
+      <a:bodyPr/>
+      <a:lstStyle/>
+      <a:style>
+        <a:lnRef idx="2">
+          <a:schemeClr val="accent1"/>
+        </a:lnRef>
+        <a:fillRef idx="0">
+          <a:schemeClr val="accent1"/>
+        </a:fillRef>
+        <a:effectRef idx="1">
+          <a:schemeClr val="accent1"/>
+        </a:effectRef>
+        <a:fontRef idx="minor">
+          <a:schemeClr val="tx1"/>
+        </a:fontRef>
+      </a:style>
+    </a:lnDef>
+  </a:objectDefaults>
+  <a:extraClrSchemeLst/>
+  <a:extLst>
+    <a:ext uri="{05A4C25C-085E-4340-85A3-A5531E510DB2}">
+      <thm15:themeFamily xmlns:thm15="http://schemas.microsoft.com/office/thememl/2012/main" name="Office Theme" id="{2E142A2C-CD16-42D6-873A-C26D2A0506FA}" vid="{1BDDFF52-6CD6-40A5-AB3C-68EB2F1E4D0A}"/>
+    </a:ext>
+  </a:extLst>
+</a:theme>
 </file>
</xml_diff>